<commit_message>
Make the deck render the same on every viewer
On an iPhone the three native PowerPoint charts (slides 9, 11, 12) rendered as
blank space, and the whole deck fell back to a serif: iOS and macOS file
previews do not draw native charts, and Calibri ships only with Office.

The charts are now images — slide 9 reuses Figure 3, and slides 11 and 12 get
two new plots in the same style, drawn by scripts/plot.py from the sweep CSV —
and the deck uses Arial, which every platform has. Arial is about 12% wider
than Calibri, so the text-fit check now measures with Arial; it flagged five
titles wrapping, fixed by setting titles at 28 pt.
</commit_message>
<xml_diff>
--- a/docs/SC6109_parallel_evm.pptx
+++ b/docs/SC6109_parallel_evm.pptx
@@ -118,1237 +118,6 @@
     </a:lvl9pPr>
   </p:defaultTextStyle>
 </p:presentation>
-</file>
-
-<file path=ppt/charts/chart1.xml><?xml version="1.0" encoding="utf-8"?>
-<c:chartSpace xmlns:c="http://schemas.openxmlformats.org/drawingml/2006/chart" xmlns:a="http://schemas.openxmlformats.org/drawingml/2006/main" xmlns:r="http://schemas.openxmlformats.org/officeDocument/2006/relationships">
-  <c:date1904 val="0"/>
-  <c:roundedCorners val="1"/>
-  <c:chart>
-    <c:title>
-      <c:tx>
-        <c:rich>
-          <a:bodyPr/>
-          <a:lstStyle/>
-          <a:p>
-            <a:pPr>
-              <a:defRPr sz="1400" b="0" i="0" u="none" strike="noStrike">
-                <a:solidFill>
-                  <a:srgbClr val="14181F"/>
-                </a:solidFill>
-                <a:latin typeface="Arial"/>
-              </a:defRPr>
-            </a:pPr>
-            <a:r>
-              <a:rPr sz="1400" b="0" i="0" u="none" strike="noStrike">
-                <a:solidFill>
-                  <a:srgbClr val="14181F"/>
-                </a:solidFill>
-                <a:latin typeface="Arial"/>
-              </a:rPr>
-              <a:t>Speedup at 6 threads vs sequential time per transaction</a:t>
-            </a:r>
-          </a:p>
-        </c:rich>
-      </c:tx>
-      <c:layout/>
-      <c:overlay val="0"/>
-    </c:title>
-    <c:autoTitleDeleted val="0"/>
-    <c:plotArea>
-      <c:layout/>
-      <c:lineChart>
-        <c:varyColors val="0"/>
-        <c:ser>
-          <c:idx val="0"/>
-          <c:order val="0"/>
-          <c:tx>
-            <c:strRef>
-              <c:f>Sheet1!$B$1</c:f>
-              <c:strCache>
-                <c:ptCount val="1"/>
-                <c:pt idx="0">
-                  <c:v>M2a round-based</c:v>
-                </c:pt>
-              </c:strCache>
-            </c:strRef>
-          </c:tx>
-          <c:spPr>
-            <a:solidFill>
-              <a:srgbClr val="2A78D6"/>
-            </a:solidFill>
-            <a:ln w="31750" cap="flat">
-              <a:solidFill>
-                <a:srgbClr val="2A78D6"/>
-              </a:solidFill>
-              <a:prstDash val="solid"/>
-              <a:round/>
-            </a:ln>
-            <a:effectLst/>
-          </c:spPr>
-          <c:invertIfNegative val="0"/>
-          <c:dLbls>
-            <c:numFmt formatCode="#,##0" sourceLinked="0"/>
-            <c:txPr>
-              <a:bodyPr/>
-              <a:lstStyle/>
-              <a:p>
-                <a:pPr>
-                  <a:defRPr b="0" i="0" strike="noStrike" sz="1200" u="none">
-                    <a:solidFill>
-                      <a:srgbClr val="000000"/>
-                    </a:solidFill>
-                    <a:latin typeface="Arial"/>
-                  </a:defRPr>
-                </a:pPr>
-              </a:p>
-            </c:txPr>
-            <c:showLegendKey val="0"/>
-            <c:showVal val="0"/>
-            <c:showCatName val="0"/>
-            <c:showSerName val="0"/>
-            <c:showPercent val="0"/>
-            <c:showBubbleSize val="0"/>
-            <c:showLeaderLines val="0"/>
-          </c:dLbls>
-          <c:marker>
-            <c:symbol val="circle"/>
-            <c:size val="9"/>
-            <c:spPr>
-              <a:solidFill>
-                <a:srgbClr val="2A78D6"/>
-              </a:solidFill>
-              <a:ln w="9525" cap="flat">
-                <a:solidFill>
-                  <a:srgbClr val="2A78D6"/>
-                </a:solidFill>
-                <a:prstDash val="solid"/>
-                <a:round/>
-              </a:ln>
-              <a:effectLst/>
-            </c:spPr>
-          </c:marker>
-          <c:cat>
-            <c:multiLvlStrRef>
-              <c:f>Sheet1!$A$2:$A$5</c:f>
-              <c:multiLvlStrCache>
-                <c:ptCount val="4"/>
-                <c:lvl>
-                  <c:pt idx="0">
-                    <c:v>1.6 µs (0 B)</c:v>
-                  </c:pt>
-                  <c:pt idx="1">
-                    <c:v>4.1 µs (1 KB)</c:v>
-                  </c:pt>
-                  <c:pt idx="2">
-                    <c:v>21 µs (8 KB)</c:v>
-                  </c:pt>
-                  <c:pt idx="3">
-                    <c:v>78 µs (32 KB)</c:v>
-                  </c:pt>
-                </c:lvl>
-              </c:multiLvlStrCache>
-            </c:multiLvlStrRef>
-          </c:cat>
-          <c:val>
-            <c:numRef>
-              <c:f>Sheet1!$B$2:$B$5</c:f>
-              <c:numCache>
-                <c:formatCode>General</c:formatCode>
-                <c:ptCount val="4"/>
-                <c:pt idx="0">
-                  <c:v>1.07</c:v>
-                </c:pt>
-                <c:pt idx="1">
-                  <c:v>3.11</c:v>
-                </c:pt>
-                <c:pt idx="2">
-                  <c:v>5.05</c:v>
-                </c:pt>
-                <c:pt idx="3">
-                  <c:v>5.51</c:v>
-                </c:pt>
-              </c:numCache>
-            </c:numRef>
-          </c:val>
-          <c:smooth val="0"/>
-        </c:ser>
-        <c:ser>
-          <c:idx val="1"/>
-          <c:order val="1"/>
-          <c:tx>
-            <c:strRef>
-              <c:f>Sheet1!$C$1</c:f>
-              <c:strCache>
-                <c:ptCount val="1"/>
-                <c:pt idx="0">
-                  <c:v>M2b Block-STM</c:v>
-                </c:pt>
-              </c:strCache>
-            </c:strRef>
-          </c:tx>
-          <c:spPr>
-            <a:solidFill>
-              <a:srgbClr val="EB6834"/>
-            </a:solidFill>
-            <a:ln w="31750" cap="flat">
-              <a:solidFill>
-                <a:srgbClr val="EB6834"/>
-              </a:solidFill>
-              <a:prstDash val="solid"/>
-              <a:round/>
-            </a:ln>
-            <a:effectLst/>
-          </c:spPr>
-          <c:invertIfNegative val="0"/>
-          <c:dLbls>
-            <c:numFmt formatCode="#,##0" sourceLinked="0"/>
-            <c:txPr>
-              <a:bodyPr/>
-              <a:lstStyle/>
-              <a:p>
-                <a:pPr>
-                  <a:defRPr b="0" i="0" strike="noStrike" sz="1200" u="none">
-                    <a:solidFill>
-                      <a:srgbClr val="000000"/>
-                    </a:solidFill>
-                    <a:latin typeface="Arial"/>
-                  </a:defRPr>
-                </a:pPr>
-              </a:p>
-            </c:txPr>
-            <c:showLegendKey val="0"/>
-            <c:showVal val="0"/>
-            <c:showCatName val="0"/>
-            <c:showSerName val="0"/>
-            <c:showPercent val="0"/>
-            <c:showBubbleSize val="0"/>
-            <c:showLeaderLines val="0"/>
-          </c:dLbls>
-          <c:marker>
-            <c:symbol val="circle"/>
-            <c:size val="9"/>
-            <c:spPr>
-              <a:solidFill>
-                <a:srgbClr val="EB6834"/>
-              </a:solidFill>
-              <a:ln w="9525" cap="flat">
-                <a:solidFill>
-                  <a:srgbClr val="EB6834"/>
-                </a:solidFill>
-                <a:prstDash val="solid"/>
-                <a:round/>
-              </a:ln>
-              <a:effectLst/>
-            </c:spPr>
-          </c:marker>
-          <c:cat>
-            <c:multiLvlStrRef>
-              <c:f>Sheet1!$A$2:$A$5</c:f>
-              <c:multiLvlStrCache>
-                <c:ptCount val="4"/>
-                <c:lvl>
-                  <c:pt idx="0">
-                    <c:v>1.6 µs (0 B)</c:v>
-                  </c:pt>
-                  <c:pt idx="1">
-                    <c:v>4.1 µs (1 KB)</c:v>
-                  </c:pt>
-                  <c:pt idx="2">
-                    <c:v>21 µs (8 KB)</c:v>
-                  </c:pt>
-                  <c:pt idx="3">
-                    <c:v>78 µs (32 KB)</c:v>
-                  </c:pt>
-                </c:lvl>
-              </c:multiLvlStrCache>
-            </c:multiLvlStrRef>
-          </c:cat>
-          <c:val>
-            <c:numRef>
-              <c:f>Sheet1!$C$2:$C$5</c:f>
-              <c:numCache>
-                <c:formatCode>General</c:formatCode>
-                <c:ptCount val="4"/>
-                <c:pt idx="0">
-                  <c:v>1.61</c:v>
-                </c:pt>
-                <c:pt idx="1">
-                  <c:v>3.18</c:v>
-                </c:pt>
-                <c:pt idx="2">
-                  <c:v>5.16</c:v>
-                </c:pt>
-                <c:pt idx="3">
-                  <c:v>5.58</c:v>
-                </c:pt>
-              </c:numCache>
-            </c:numRef>
-          </c:val>
-          <c:smooth val="0"/>
-        </c:ser>
-        <c:ser>
-          <c:idx val="2"/>
-          <c:order val="2"/>
-          <c:tx>
-            <c:strRef>
-              <c:f>Sheet1!$D$1</c:f>
-              <c:strCache>
-                <c:ptCount val="1"/>
-                <c:pt idx="0">
-                  <c:v>M3 static</c:v>
-                </c:pt>
-              </c:strCache>
-            </c:strRef>
-          </c:tx>
-          <c:spPr>
-            <a:solidFill>
-              <a:srgbClr val="1BAF7A"/>
-            </a:solidFill>
-            <a:ln w="31750" cap="flat">
-              <a:solidFill>
-                <a:srgbClr val="1BAF7A"/>
-              </a:solidFill>
-              <a:prstDash val="solid"/>
-              <a:round/>
-            </a:ln>
-            <a:effectLst/>
-          </c:spPr>
-          <c:invertIfNegative val="0"/>
-          <c:dLbls>
-            <c:numFmt formatCode="#,##0" sourceLinked="0"/>
-            <c:txPr>
-              <a:bodyPr/>
-              <a:lstStyle/>
-              <a:p>
-                <a:pPr>
-                  <a:defRPr b="0" i="0" strike="noStrike" sz="1200" u="none">
-                    <a:solidFill>
-                      <a:srgbClr val="000000"/>
-                    </a:solidFill>
-                    <a:latin typeface="Arial"/>
-                  </a:defRPr>
-                </a:pPr>
-              </a:p>
-            </c:txPr>
-            <c:showLegendKey val="0"/>
-            <c:showVal val="0"/>
-            <c:showCatName val="0"/>
-            <c:showSerName val="0"/>
-            <c:showPercent val="0"/>
-            <c:showBubbleSize val="0"/>
-            <c:showLeaderLines val="0"/>
-          </c:dLbls>
-          <c:marker>
-            <c:symbol val="circle"/>
-            <c:size val="9"/>
-            <c:spPr>
-              <a:solidFill>
-                <a:srgbClr val="1BAF7A"/>
-              </a:solidFill>
-              <a:ln w="9525" cap="flat">
-                <a:solidFill>
-                  <a:srgbClr val="1BAF7A"/>
-                </a:solidFill>
-                <a:prstDash val="solid"/>
-                <a:round/>
-              </a:ln>
-              <a:effectLst/>
-            </c:spPr>
-          </c:marker>
-          <c:cat>
-            <c:multiLvlStrRef>
-              <c:f>Sheet1!$A$2:$A$5</c:f>
-              <c:multiLvlStrCache>
-                <c:ptCount val="4"/>
-                <c:lvl>
-                  <c:pt idx="0">
-                    <c:v>1.6 µs (0 B)</c:v>
-                  </c:pt>
-                  <c:pt idx="1">
-                    <c:v>4.1 µs (1 KB)</c:v>
-                  </c:pt>
-                  <c:pt idx="2">
-                    <c:v>21 µs (8 KB)</c:v>
-                  </c:pt>
-                  <c:pt idx="3">
-                    <c:v>78 µs (32 KB)</c:v>
-                  </c:pt>
-                </c:lvl>
-              </c:multiLvlStrCache>
-            </c:multiLvlStrRef>
-          </c:cat>
-          <c:val>
-            <c:numRef>
-              <c:f>Sheet1!$D$2:$D$5</c:f>
-              <c:numCache>
-                <c:formatCode>General</c:formatCode>
-                <c:ptCount val="4"/>
-                <c:pt idx="0">
-                  <c:v>1.8</c:v>
-                </c:pt>
-                <c:pt idx="1">
-                  <c:v>3.58</c:v>
-                </c:pt>
-                <c:pt idx="2">
-                  <c:v>5.29</c:v>
-                </c:pt>
-                <c:pt idx="3">
-                  <c:v>5.46</c:v>
-                </c:pt>
-              </c:numCache>
-            </c:numRef>
-          </c:val>
-          <c:smooth val="0"/>
-        </c:ser>
-        <c:dLbls>
-          <c:numFmt formatCode="#,##0" sourceLinked="0"/>
-          <c:txPr>
-            <a:bodyPr/>
-            <a:lstStyle/>
-            <a:p>
-              <a:pPr>
-                <a:defRPr b="0" i="0" strike="noStrike" sz="1200" u="none">
-                  <a:solidFill>
-                    <a:srgbClr val="000000"/>
-                  </a:solidFill>
-                  <a:latin typeface="Arial"/>
-                </a:defRPr>
-              </a:pPr>
-            </a:p>
-          </c:txPr>
-          <c:showLegendKey val="0"/>
-          <c:showVal val="0"/>
-          <c:showCatName val="0"/>
-          <c:showSerName val="0"/>
-          <c:showPercent val="0"/>
-          <c:showBubbleSize val="0"/>
-          <c:showLeaderLines val="0"/>
-        </c:dLbls>
-        <c:marker val="1"/>
-        <c:axId val="2094734554"/>
-        <c:axId val="2094734552"/>
-        <c:axId val="2094734556"/>
-      </c:lineChart>
-      <c:catAx>
-        <c:axId val="2094734554"/>
-        <c:scaling>
-          <c:orientation val="minMax"/>
-        </c:scaling>
-        <c:delete val="0"/>
-        <c:axPos val="b"/>
-        <c:numFmt formatCode="General" sourceLinked="1"/>
-        <c:majorTickMark val="out"/>
-        <c:minorTickMark val="none"/>
-        <c:tickLblPos val="low"/>
-        <c:spPr>
-          <a:ln w="12700" cap="flat">
-            <a:solidFill>
-              <a:srgbClr val="888888"/>
-            </a:solidFill>
-            <a:prstDash val="solid"/>
-            <a:round/>
-          </a:ln>
-        </c:spPr>
-        <c:txPr>
-          <a:bodyPr/>
-          <a:lstStyle/>
-          <a:p>
-            <a:pPr>
-              <a:defRPr sz="1200" b="0" i="0" u="none" strike="noStrike">
-                <a:solidFill>
-                  <a:srgbClr val="5A6272"/>
-                </a:solidFill>
-                <a:latin typeface="Arial"/>
-              </a:defRPr>
-            </a:pPr>
-            <a:endParaRPr lang="en-US"/>
-          </a:p>
-        </c:txPr>
-        <c:crossAx val="2094734552"/>
-        <c:crosses val="autoZero"/>
-        <c:auto val="1"/>
-        <c:lblAlgn val="ctr"/>
-        <c:noMultiLvlLbl val="1"/>
-      </c:catAx>
-      <c:valAx>
-        <c:axId val="2094734552"/>
-        <c:scaling>
-          <c:orientation val="minMax"/>
-          <c:max val="6"/>
-          <c:min val="0"/>
-        </c:scaling>
-        <c:delete val="0"/>
-        <c:axPos val="l"/>
-        <c:majorGridlines>
-          <c:spPr>
-            <a:ln w="12700" cap="flat">
-              <a:solidFill>
-                <a:srgbClr val="E3E5EA"/>
-              </a:solidFill>
-              <a:prstDash val="solid"/>
-              <a:round/>
-            </a:ln>
-          </c:spPr>
-        </c:majorGridlines>
-        <c:title>
-          <c:tx>
-            <c:rich>
-              <a:bodyPr/>
-              <a:lstStyle/>
-              <a:p>
-                <a:pPr>
-                  <a:defRPr sz="1200" b="0" i="0" u="none" strike="noStrike">
-                    <a:solidFill>
-                      <a:srgbClr val="5A6272"/>
-                    </a:solidFill>
-                    <a:latin typeface="Arial"/>
-                  </a:defRPr>
-                </a:pPr>
-                <a:r>
-                  <a:rPr sz="1200" b="0" i="0" u="none" strike="noStrike">
-                    <a:solidFill>
-                      <a:srgbClr val="5A6272"/>
-                    </a:solidFill>
-                    <a:latin typeface="Arial"/>
-                  </a:rPr>
-                  <a:t>speedup</a:t>
-                </a:r>
-              </a:p>
-            </c:rich>
-          </c:tx>
-          <c:layout/>
-          <c:overlay val="0"/>
-        </c:title>
-        <c:numFmt formatCode="General" sourceLinked="0"/>
-        <c:majorTickMark val="out"/>
-        <c:minorTickMark val="none"/>
-        <c:tickLblPos val="nextTo"/>
-        <c:spPr>
-          <a:ln w="12700" cap="flat">
-            <a:solidFill>
-              <a:srgbClr val="888888"/>
-            </a:solidFill>
-            <a:prstDash val="solid"/>
-            <a:round/>
-          </a:ln>
-        </c:spPr>
-        <c:txPr>
-          <a:bodyPr/>
-          <a:lstStyle/>
-          <a:p>
-            <a:pPr>
-              <a:defRPr sz="1200" b="0" i="0" u="none" strike="noStrike">
-                <a:solidFill>
-                  <a:srgbClr val="5A6272"/>
-                </a:solidFill>
-                <a:latin typeface="Arial"/>
-              </a:defRPr>
-            </a:pPr>
-            <a:endParaRPr lang="en-US"/>
-          </a:p>
-        </c:txPr>
-        <c:crossAx val="2094734554"/>
-        <c:crosses val="autoZero"/>
-        <c:crossBetween val="between"/>
-        <c:majorUnit val="1"/>
-      </c:valAx>
-      <c:spPr>
-        <a:noFill/>
-        <a:ln>
-          <a:noFill/>
-        </a:ln>
-        <a:effectLst/>
-      </c:spPr>
-    </c:plotArea>
-    <c:legend>
-      <c:legendPos val="b"/>
-      <c:overlay val="0"/>
-      <c:txPr>
-        <a:bodyPr/>
-        <a:lstStyle/>
-        <a:p>
-          <a:pPr>
-            <a:defRPr sz="1200">
-              <a:solidFill>
-                <a:srgbClr val="14181F"/>
-              </a:solidFill>
-            </a:defRPr>
-          </a:pPr>
-          <a:endParaRPr lang="en-US"/>
-        </a:p>
-      </c:txPr>
-    </c:legend>
-    <c:plotVisOnly val="1"/>
-    <c:dispBlanksAs val="span"/>
-  </c:chart>
-  <c:spPr>
-    <a:noFill/>
-    <a:ln>
-      <a:noFill/>
-    </a:ln>
-    <a:effectLst/>
-  </c:spPr>
-  <c:externalData r:id="rId1">
-    <c:autoUpdate val="0"/>
-  </c:externalData>
-</c:chartSpace>
-</file>
-
-<file path=ppt/charts/chart2.xml><?xml version="1.0" encoding="utf-8"?>
-<c:chartSpace xmlns:c="http://schemas.openxmlformats.org/drawingml/2006/chart" xmlns:a="http://schemas.openxmlformats.org/drawingml/2006/main" xmlns:r="http://schemas.openxmlformats.org/officeDocument/2006/relationships">
-  <c:date1904 val="0"/>
-  <c:roundedCorners val="1"/>
-  <c:chart>
-    <c:title>
-      <c:tx>
-        <c:rich>
-          <a:bodyPr/>
-          <a:lstStyle/>
-          <a:p>
-            <a:pPr>
-              <a:defRPr sz="1400" b="0" i="0" u="none" strike="noStrike">
-                <a:solidFill>
-                  <a:srgbClr val="14181F"/>
-                </a:solidFill>
-                <a:latin typeface="Arial"/>
-              </a:defRPr>
-            </a:pPr>
-            <a:r>
-              <a:rPr sz="1400" b="0" i="0" u="none" strike="noStrike">
-                <a:solidFill>
-                  <a:srgbClr val="14181F"/>
-                </a:solidFill>
-                <a:latin typeface="Arial"/>
-              </a:rPr>
-              <a:t>ERC-20 transfers among many holders, speedup at 6 threads</a:t>
-            </a:r>
-          </a:p>
-        </c:rich>
-      </c:tx>
-      <c:layout/>
-      <c:overlay val="0"/>
-    </c:title>
-    <c:autoTitleDeleted val="0"/>
-    <c:plotArea>
-      <c:layout/>
-      <c:barChart>
-        <c:barDir val="col"/>
-        <c:grouping val="clustered"/>
-        <c:varyColors val="0"/>
-        <c:ser>
-          <c:idx val="0"/>
-          <c:order val="0"/>
-          <c:tx>
-            <c:strRef>
-              <c:f>Sheet1!$B$1</c:f>
-              <c:strCache>
-                <c:ptCount val="1"/>
-                <c:pt idx="0">
-                  <c:v>per storage slot</c:v>
-                </c:pt>
-              </c:strCache>
-            </c:strRef>
-          </c:tx>
-          <c:spPr>
-            <a:solidFill>
-              <a:srgbClr val="2A78D6"/>
-            </a:solidFill>
-            <a:effectLst/>
-          </c:spPr>
-          <c:invertIfNegative val="0"/>
-          <c:dLbls>
-            <c:numFmt formatCode="0.00&quot;×&quot;" sourceLinked="0"/>
-            <c:txPr>
-              <a:bodyPr/>
-              <a:lstStyle/>
-              <a:p>
-                <a:pPr>
-                  <a:defRPr b="0" i="0" strike="noStrike" sz="1200" u="none">
-                    <a:solidFill>
-                      <a:srgbClr val="14181F"/>
-                    </a:solidFill>
-                    <a:latin typeface="Arial"/>
-                  </a:defRPr>
-                </a:pPr>
-              </a:p>
-            </c:txPr>
-            <c:showLegendKey val="0"/>
-            <c:showVal val="1"/>
-            <c:showCatName val="0"/>
-            <c:showSerName val="0"/>
-            <c:showPercent val="0"/>
-            <c:showBubbleSize val="0"/>
-            <c:showLeaderLines val="0"/>
-          </c:dLbls>
-          <c:cat>
-            <c:multiLvlStrRef>
-              <c:f>Sheet1!$A$2:$A$4</c:f>
-              <c:multiLvlStrCache>
-                <c:ptCount val="3"/>
-                <c:lvl>
-                  <c:pt idx="0">
-                    <c:v>M2a round-based</c:v>
-                  </c:pt>
-                  <c:pt idx="1">
-                    <c:v>M2b Block-STM</c:v>
-                  </c:pt>
-                  <c:pt idx="2">
-                    <c:v>M3 static</c:v>
-                  </c:pt>
-                </c:lvl>
-              </c:multiLvlStrCache>
-            </c:multiLvlStrRef>
-          </c:cat>
-          <c:val>
-            <c:numRef>
-              <c:f>Sheet1!$B$2:$B$4</c:f>
-              <c:numCache>
-                <c:formatCode>General</c:formatCode>
-                <c:ptCount val="3"/>
-                <c:pt idx="0">
-                  <c:v>2.87</c:v>
-                </c:pt>
-                <c:pt idx="1">
-                  <c:v>2.92</c:v>
-                </c:pt>
-                <c:pt idx="2">
-                  <c:v>3.1</c:v>
-                </c:pt>
-              </c:numCache>
-            </c:numRef>
-          </c:val>
-        </c:ser>
-        <c:ser>
-          <c:idx val="1"/>
-          <c:order val="1"/>
-          <c:tx>
-            <c:strRef>
-              <c:f>Sheet1!$C$1</c:f>
-              <c:strCache>
-                <c:ptCount val="1"/>
-                <c:pt idx="0">
-                  <c:v>per account</c:v>
-                </c:pt>
-              </c:strCache>
-            </c:strRef>
-          </c:tx>
-          <c:spPr>
-            <a:solidFill>
-              <a:srgbClr val="EB6834"/>
-            </a:solidFill>
-            <a:effectLst/>
-          </c:spPr>
-          <c:invertIfNegative val="0"/>
-          <c:dLbls>
-            <c:numFmt formatCode="0.00&quot;×&quot;" sourceLinked="0"/>
-            <c:txPr>
-              <a:bodyPr/>
-              <a:lstStyle/>
-              <a:p>
-                <a:pPr>
-                  <a:defRPr b="0" i="0" strike="noStrike" sz="1200" u="none">
-                    <a:solidFill>
-                      <a:srgbClr val="14181F"/>
-                    </a:solidFill>
-                    <a:latin typeface="Arial"/>
-                  </a:defRPr>
-                </a:pPr>
-              </a:p>
-            </c:txPr>
-            <c:showLegendKey val="0"/>
-            <c:showVal val="1"/>
-            <c:showCatName val="0"/>
-            <c:showSerName val="0"/>
-            <c:showPercent val="0"/>
-            <c:showBubbleSize val="0"/>
-            <c:showLeaderLines val="0"/>
-          </c:dLbls>
-          <c:cat>
-            <c:multiLvlStrRef>
-              <c:f>Sheet1!$A$2:$A$4</c:f>
-              <c:multiLvlStrCache>
-                <c:ptCount val="3"/>
-                <c:lvl>
-                  <c:pt idx="0">
-                    <c:v>M2a round-based</c:v>
-                  </c:pt>
-                  <c:pt idx="1">
-                    <c:v>M2b Block-STM</c:v>
-                  </c:pt>
-                  <c:pt idx="2">
-                    <c:v>M3 static</c:v>
-                  </c:pt>
-                </c:lvl>
-              </c:multiLvlStrCache>
-            </c:multiLvlStrRef>
-          </c:cat>
-          <c:val>
-            <c:numRef>
-              <c:f>Sheet1!$C$2:$C$4</c:f>
-              <c:numCache>
-                <c:formatCode>General</c:formatCode>
-                <c:ptCount val="3"/>
-                <c:pt idx="0">
-                  <c:v>0.01</c:v>
-                </c:pt>
-                <c:pt idx="1">
-                  <c:v>0.5</c:v>
-                </c:pt>
-                <c:pt idx="2">
-                  <c:v>0.31</c:v>
-                </c:pt>
-              </c:numCache>
-            </c:numRef>
-          </c:val>
-        </c:ser>
-        <c:dLbls>
-          <c:numFmt formatCode="0.00&quot;×&quot;" sourceLinked="0"/>
-          <c:txPr>
-            <a:bodyPr/>
-            <a:lstStyle/>
-            <a:p>
-              <a:pPr>
-                <a:defRPr b="0" i="0" strike="noStrike" sz="1200" u="none">
-                  <a:solidFill>
-                    <a:srgbClr val="14181F"/>
-                  </a:solidFill>
-                  <a:latin typeface="Arial"/>
-                </a:defRPr>
-              </a:pPr>
-            </a:p>
-          </c:txPr>
-          <c:showLegendKey val="0"/>
-          <c:showVal val="1"/>
-          <c:showCatName val="0"/>
-          <c:showSerName val="0"/>
-          <c:showPercent val="0"/>
-          <c:showBubbleSize val="0"/>
-          <c:showLeaderLines val="0"/>
-        </c:dLbls>
-        <c:gapWidth val="60"/>
-        <c:overlap val="0"/>
-        <c:axId val="2094734554"/>
-        <c:axId val="2094734552"/>
-        <c:axId val="2094734556"/>
-      </c:barChart>
-      <c:catAx>
-        <c:axId val="2094734554"/>
-        <c:scaling>
-          <c:orientation val="minMax"/>
-        </c:scaling>
-        <c:delete val="0"/>
-        <c:axPos val="b"/>
-        <c:numFmt formatCode="General" sourceLinked="1"/>
-        <c:majorTickMark val="out"/>
-        <c:minorTickMark val="none"/>
-        <c:tickLblPos val="low"/>
-        <c:spPr>
-          <a:ln w="12700" cap="flat">
-            <a:solidFill>
-              <a:srgbClr val="888888"/>
-            </a:solidFill>
-            <a:prstDash val="solid"/>
-            <a:round/>
-          </a:ln>
-        </c:spPr>
-        <c:txPr>
-          <a:bodyPr/>
-          <a:lstStyle/>
-          <a:p>
-            <a:pPr>
-              <a:defRPr sz="1300" b="0" i="0" u="none" strike="noStrike">
-                <a:solidFill>
-                  <a:srgbClr val="14181F"/>
-                </a:solidFill>
-                <a:latin typeface="Arial"/>
-              </a:defRPr>
-            </a:pPr>
-            <a:endParaRPr lang="en-US"/>
-          </a:p>
-        </c:txPr>
-        <c:crossAx val="2094734552"/>
-        <c:crosses val="autoZero"/>
-        <c:auto val="1"/>
-        <c:lblAlgn val="ctr"/>
-        <c:noMultiLvlLbl val="1"/>
-      </c:catAx>
-      <c:valAx>
-        <c:axId val="2094734552"/>
-        <c:scaling>
-          <c:orientation val="minMax"/>
-          <c:max val="3.5"/>
-          <c:min val="0"/>
-        </c:scaling>
-        <c:delete val="0"/>
-        <c:axPos val="l"/>
-        <c:majorGridlines>
-          <c:spPr>
-            <a:ln w="12700" cap="flat">
-              <a:solidFill>
-                <a:srgbClr val="E3E5EA"/>
-              </a:solidFill>
-              <a:prstDash val="solid"/>
-              <a:round/>
-            </a:ln>
-          </c:spPr>
-        </c:majorGridlines>
-        <c:numFmt formatCode="General" sourceLinked="0"/>
-        <c:majorTickMark val="out"/>
-        <c:minorTickMark val="none"/>
-        <c:tickLblPos val="nextTo"/>
-        <c:spPr>
-          <a:ln w="12700" cap="flat">
-            <a:solidFill>
-              <a:srgbClr val="888888"/>
-            </a:solidFill>
-            <a:prstDash val="solid"/>
-            <a:round/>
-          </a:ln>
-        </c:spPr>
-        <c:txPr>
-          <a:bodyPr/>
-          <a:lstStyle/>
-          <a:p>
-            <a:pPr>
-              <a:defRPr sz="1200" b="0" i="0" u="none" strike="noStrike">
-                <a:solidFill>
-                  <a:srgbClr val="5A6272"/>
-                </a:solidFill>
-                <a:latin typeface="Arial"/>
-              </a:defRPr>
-            </a:pPr>
-            <a:endParaRPr lang="en-US"/>
-          </a:p>
-        </c:txPr>
-        <c:crossAx val="2094734554"/>
-        <c:crosses val="autoZero"/>
-        <c:crossBetween val="between"/>
-        <c:majorUnit val="0.5"/>
-      </c:valAx>
-      <c:spPr>
-        <a:noFill/>
-        <a:ln>
-          <a:noFill/>
-        </a:ln>
-        <a:effectLst/>
-      </c:spPr>
-    </c:plotArea>
-    <c:legend>
-      <c:legendPos val="b"/>
-      <c:overlay val="0"/>
-      <c:txPr>
-        <a:bodyPr/>
-        <a:lstStyle/>
-        <a:p>
-          <a:pPr>
-            <a:defRPr sz="1200">
-              <a:solidFill>
-                <a:srgbClr val="14181F"/>
-              </a:solidFill>
-            </a:defRPr>
-          </a:pPr>
-          <a:endParaRPr lang="en-US"/>
-        </a:p>
-      </c:txPr>
-    </c:legend>
-    <c:plotVisOnly val="1"/>
-    <c:dispBlanksAs val="span"/>
-  </c:chart>
-  <c:spPr>
-    <a:noFill/>
-    <a:ln>
-      <a:noFill/>
-    </a:ln>
-    <a:effectLst/>
-  </c:spPr>
-  <c:externalData r:id="rId1">
-    <c:autoUpdate val="0"/>
-  </c:externalData>
-</c:chartSpace>
-</file>
-
-<file path=ppt/charts/chart3.xml><?xml version="1.0" encoding="utf-8"?>
-<c:chartSpace xmlns:c="http://schemas.openxmlformats.org/drawingml/2006/chart" xmlns:a="http://schemas.openxmlformats.org/drawingml/2006/main" xmlns:r="http://schemas.openxmlformats.org/officeDocument/2006/relationships">
-  <c:date1904 val="0"/>
-  <c:roundedCorners val="1"/>
-  <c:chart>
-    <c:title>
-      <c:tx>
-        <c:rich>
-          <a:bodyPr/>
-          <a:lstStyle/>
-          <a:p>
-            <a:pPr>
-              <a:defRPr sz="1300" b="0" i="0" u="none" strike="noStrike">
-                <a:solidFill>
-                  <a:srgbClr val="5A6272"/>
-                </a:solidFill>
-                <a:latin typeface="Arial"/>
-              </a:defRPr>
-            </a:pPr>
-            <a:r>
-              <a:rPr sz="1300" b="0" i="0" u="none" strike="noStrike">
-                <a:solidFill>
-                  <a:srgbClr val="5A6272"/>
-                </a:solidFill>
-                <a:latin typeface="Arial"/>
-              </a:rPr>
-              <a:t>Speedup over sequential (1.0 = no gain)</a:t>
-            </a:r>
-          </a:p>
-        </c:rich>
-      </c:tx>
-      <c:layout/>
-      <c:overlay val="0"/>
-    </c:title>
-    <c:autoTitleDeleted val="0"/>
-    <c:plotArea>
-      <c:layout/>
-      <c:barChart>
-        <c:barDir val="bar"/>
-        <c:grouping val="clustered"/>
-        <c:varyColors val="0"/>
-        <c:ser>
-          <c:idx val="0"/>
-          <c:order val="0"/>
-          <c:tx>
-            <c:strRef>
-              <c:f>Sheet1!$B$1</c:f>
-              <c:strCache>
-                <c:ptCount val="1"/>
-                <c:pt idx="0">
-                  <c:v>Block-STM, 6 threads</c:v>
-                </c:pt>
-              </c:strCache>
-            </c:strRef>
-          </c:tx>
-          <c:spPr>
-            <a:solidFill>
-              <a:srgbClr val="EB6834"/>
-            </a:solidFill>
-            <a:effectLst/>
-          </c:spPr>
-          <c:invertIfNegative val="0"/>
-          <c:dLbls>
-            <c:numFmt formatCode="0.00&quot;×&quot;" sourceLinked="0"/>
-            <c:txPr>
-              <a:bodyPr/>
-              <a:lstStyle/>
-              <a:p>
-                <a:pPr>
-                  <a:defRPr b="0" i="0" strike="noStrike" sz="1200" u="none">
-                    <a:solidFill>
-                      <a:srgbClr val="14181F"/>
-                    </a:solidFill>
-                    <a:latin typeface="Arial"/>
-                  </a:defRPr>
-                </a:pPr>
-              </a:p>
-            </c:txPr>
-            <c:showLegendKey val="0"/>
-            <c:showVal val="1"/>
-            <c:showCatName val="0"/>
-            <c:showSerName val="0"/>
-            <c:showPercent val="0"/>
-            <c:showBubbleSize val="0"/>
-            <c:showLeaderLines val="0"/>
-          </c:dLbls>
-          <c:cat>
-            <c:multiLvlStrRef>
-              <c:f>Sheet1!$A$2:$A$6</c:f>
-              <c:multiLvlStrCache>
-                <c:ptCount val="5"/>
-                <c:lvl>
-                  <c:pt idx="0">
-                    <c:v>compute-heavy, independent</c:v>
-                  </c:pt>
-                  <c:pt idx="1">
-                    <c:v>ERC-20, many holders</c:v>
-                  </c:pt>
-                  <c:pt idx="2">
-                    <c:v>ETH transfers, independent</c:v>
-                  </c:pt>
-                  <c:pt idx="3">
-                    <c:v>ERC-20, per-account detection</c:v>
-                  </c:pt>
-                  <c:pt idx="4">
-                    <c:v>NFT mint (one chain)</c:v>
-                  </c:pt>
-                </c:lvl>
-              </c:multiLvlStrCache>
-            </c:multiLvlStrRef>
-          </c:cat>
-          <c:val>
-            <c:numRef>
-              <c:f>Sheet1!$B$2:$B$6</c:f>
-              <c:numCache>
-                <c:formatCode>General</c:formatCode>
-                <c:ptCount val="5"/>
-                <c:pt idx="0">
-                  <c:v>5.58</c:v>
-                </c:pt>
-                <c:pt idx="1">
-                  <c:v>2.8</c:v>
-                </c:pt>
-                <c:pt idx="2">
-                  <c:v>1.41</c:v>
-                </c:pt>
-                <c:pt idx="3">
-                  <c:v>0.5</c:v>
-                </c:pt>
-                <c:pt idx="4">
-                  <c:v>0.43</c:v>
-                </c:pt>
-              </c:numCache>
-            </c:numRef>
-          </c:val>
-        </c:ser>
-        <c:dLbls>
-          <c:numFmt formatCode="0.00&quot;×&quot;" sourceLinked="0"/>
-          <c:txPr>
-            <a:bodyPr/>
-            <a:lstStyle/>
-            <a:p>
-              <a:pPr>
-                <a:defRPr b="0" i="0" strike="noStrike" sz="1200" u="none">
-                  <a:solidFill>
-                    <a:srgbClr val="14181F"/>
-                  </a:solidFill>
-                  <a:latin typeface="Arial"/>
-                </a:defRPr>
-              </a:pPr>
-            </a:p>
-          </c:txPr>
-          <c:showLegendKey val="0"/>
-          <c:showVal val="1"/>
-          <c:showCatName val="0"/>
-          <c:showSerName val="0"/>
-          <c:showPercent val="0"/>
-          <c:showBubbleSize val="0"/>
-          <c:showLeaderLines val="0"/>
-        </c:dLbls>
-        <c:gapWidth val="45"/>
-        <c:overlap val="0"/>
-        <c:axId val="2094734554"/>
-        <c:axId val="2094734552"/>
-        <c:axId val="2094734556"/>
-      </c:barChart>
-      <c:catAx>
-        <c:axId val="2094734554"/>
-        <c:scaling>
-          <c:orientation val="maxMin"/>
-        </c:scaling>
-        <c:delete val="0"/>
-        <c:axPos val="l"/>
-        <c:numFmt formatCode="General" sourceLinked="1"/>
-        <c:majorTickMark val="out"/>
-        <c:minorTickMark val="none"/>
-        <c:tickLblPos val="nextTo"/>
-        <c:spPr>
-          <a:ln w="12700" cap="flat">
-            <a:solidFill>
-              <a:srgbClr val="888888"/>
-            </a:solidFill>
-            <a:prstDash val="solid"/>
-            <a:round/>
-          </a:ln>
-        </c:spPr>
-        <c:txPr>
-          <a:bodyPr/>
-          <a:lstStyle/>
-          <a:p>
-            <a:pPr>
-              <a:defRPr sz="1200" b="0" i="0" u="none" strike="noStrike">
-                <a:solidFill>
-                  <a:srgbClr val="14181F"/>
-                </a:solidFill>
-                <a:latin typeface="Arial"/>
-              </a:defRPr>
-            </a:pPr>
-            <a:endParaRPr lang="en-US"/>
-          </a:p>
-        </c:txPr>
-        <c:crossAx val="2094734552"/>
-        <c:crosses val="autoZero"/>
-        <c:auto val="1"/>
-        <c:lblAlgn val="ctr"/>
-        <c:noMultiLvlLbl val="1"/>
-      </c:catAx>
-      <c:valAx>
-        <c:axId val="2094734552"/>
-        <c:scaling>
-          <c:orientation val="minMax"/>
-          <c:max val="6.5"/>
-          <c:min val="0"/>
-        </c:scaling>
-        <c:delete val="0"/>
-        <c:axPos val="b"/>
-        <c:majorGridlines>
-          <c:spPr>
-            <a:ln w="12700" cap="flat">
-              <a:solidFill>
-                <a:srgbClr val="E3E5EA"/>
-              </a:solidFill>
-              <a:prstDash val="solid"/>
-              <a:round/>
-            </a:ln>
-          </c:spPr>
-        </c:majorGridlines>
-        <c:numFmt formatCode="General" sourceLinked="0"/>
-        <c:majorTickMark val="out"/>
-        <c:minorTickMark val="none"/>
-        <c:tickLblPos val="low"/>
-        <c:spPr>
-          <a:ln w="12700" cap="flat">
-            <a:solidFill>
-              <a:srgbClr val="888888"/>
-            </a:solidFill>
-            <a:prstDash val="solid"/>
-            <a:round/>
-          </a:ln>
-        </c:spPr>
-        <c:txPr>
-          <a:bodyPr/>
-          <a:lstStyle/>
-          <a:p>
-            <a:pPr>
-              <a:defRPr sz="1100" b="0" i="0" u="none" strike="noStrike">
-                <a:solidFill>
-                  <a:srgbClr val="5A6272"/>
-                </a:solidFill>
-                <a:latin typeface="Arial"/>
-              </a:defRPr>
-            </a:pPr>
-            <a:endParaRPr lang="en-US"/>
-          </a:p>
-        </c:txPr>
-        <c:crossAx val="2094734554"/>
-        <c:crosses val="autoZero"/>
-        <c:crossBetween val="between"/>
-      </c:valAx>
-      <c:spPr>
-        <a:noFill/>
-        <a:ln>
-          <a:noFill/>
-        </a:ln>
-        <a:effectLst/>
-      </c:spPr>
-    </c:plotArea>
-    <c:plotVisOnly val="1"/>
-    <c:dispBlanksAs val="span"/>
-  </c:chart>
-  <c:spPr>
-    <a:noFill/>
-    <a:ln>
-      <a:noFill/>
-    </a:ln>
-    <a:effectLst/>
-  </c:spPr>
-  <c:externalData r:id="rId1">
-    <c:autoUpdate val="0"/>
-  </c:externalData>
-</c:chartSpace>
 </file>
 
 <file path=ppt/notesMasters/notesMaster1.xml><?xml version="1.0" encoding="utf-8"?>
@@ -3292,9 +2061,9 @@
                 <a:solidFill>
                   <a:srgbClr val="EB6834"/>
                 </a:solidFill>
-                <a:latin typeface="Calibri" pitchFamily="34" charset="0"/>
-                <a:ea typeface="Calibri" pitchFamily="34" charset="-122"/>
-                <a:cs typeface="Calibri" pitchFamily="34" charset="-120"/>
+                <a:latin typeface="Arial" pitchFamily="34" charset="0"/>
+                <a:ea typeface="Arial" pitchFamily="34" charset="-122"/>
+                <a:cs typeface="Arial" pitchFamily="34" charset="-120"/>
               </a:rPr>
               <a:t>SC6109 BLOCKCHAIN SCALABILITY · OPTION 5</a:t>
             </a:r>
@@ -3331,9 +2100,9 @@
                 <a:solidFill>
                   <a:srgbClr val="FFFFFF"/>
                 </a:solidFill>
-                <a:latin typeface="Calibri" pitchFamily="34" charset="0"/>
-                <a:ea typeface="Calibri" pitchFamily="34" charset="-122"/>
-                <a:cs typeface="Calibri" pitchFamily="34" charset="-120"/>
+                <a:latin typeface="Arial" pitchFamily="34" charset="0"/>
+                <a:ea typeface="Arial" pitchFamily="34" charset="-122"/>
+                <a:cs typeface="Arial" pitchFamily="34" charset="-120"/>
               </a:rPr>
               <a:t>When does parallel EVM execution pay?</a:t>
             </a:r>
@@ -3370,9 +2139,9 @@
                 <a:solidFill>
                   <a:srgbClr val="AEB6C8"/>
                 </a:solidFill>
-                <a:latin typeface="Calibri" pitchFamily="34" charset="0"/>
-                <a:ea typeface="Calibri" pitchFamily="34" charset="-122"/>
-                <a:cs typeface="Calibri" pitchFamily="34" charset="-120"/>
+                <a:latin typeface="Arial" pitchFamily="34" charset="0"/>
+                <a:ea typeface="Arial" pitchFamily="34" charset="-122"/>
+                <a:cs typeface="Arial" pitchFamily="34" charset="-120"/>
               </a:rPr>
               <a:t>A Block-STM engine over real EVM bytecode — three schedulers, twenty workloads, and the cases where parallelism makes things slower.</a:t>
             </a:r>
@@ -3436,9 +2205,9 @@
                 <a:solidFill>
                   <a:srgbClr val="1BAF7A"/>
                 </a:solidFill>
-                <a:latin typeface="Calibri" pitchFamily="34" charset="0"/>
-                <a:ea typeface="Calibri" pitchFamily="34" charset="-122"/>
-                <a:cs typeface="Calibri" pitchFamily="34" charset="-120"/>
+                <a:latin typeface="Arial" pitchFamily="34" charset="0"/>
+                <a:ea typeface="Arial" pitchFamily="34" charset="-122"/>
+                <a:cs typeface="Arial" pitchFamily="34" charset="-120"/>
               </a:rPr>
               <a:t>5.6×</a:t>
             </a:r>
@@ -3475,9 +2244,9 @@
                 <a:solidFill>
                   <a:srgbClr val="AEB6C8"/>
                 </a:solidFill>
-                <a:latin typeface="Calibri" pitchFamily="34" charset="0"/>
-                <a:ea typeface="Calibri" pitchFamily="34" charset="-122"/>
-                <a:cs typeface="Calibri" pitchFamily="34" charset="-120"/>
+                <a:latin typeface="Arial" pitchFamily="34" charset="0"/>
+                <a:ea typeface="Arial" pitchFamily="34" charset="-122"/>
+                <a:cs typeface="Arial" pitchFamily="34" charset="-120"/>
               </a:rPr>
               <a:t>independent, compute-heavy</a:t>
             </a:r>
@@ -3541,9 +2310,9 @@
                 <a:solidFill>
                   <a:srgbClr val="EB6834"/>
                 </a:solidFill>
-                <a:latin typeface="Calibri" pitchFamily="34" charset="0"/>
-                <a:ea typeface="Calibri" pitchFamily="34" charset="-122"/>
-                <a:cs typeface="Calibri" pitchFamily="34" charset="-120"/>
+                <a:latin typeface="Arial" pitchFamily="34" charset="0"/>
+                <a:ea typeface="Arial" pitchFamily="34" charset="-122"/>
+                <a:cs typeface="Arial" pitchFamily="34" charset="-120"/>
               </a:rPr>
               <a:t>0.43×</a:t>
             </a:r>
@@ -3580,9 +2349,9 @@
                 <a:solidFill>
                   <a:srgbClr val="AEB6C8"/>
                 </a:solidFill>
-                <a:latin typeface="Calibri" pitchFamily="34" charset="0"/>
-                <a:ea typeface="Calibri" pitchFamily="34" charset="-122"/>
-                <a:cs typeface="Calibri" pitchFamily="34" charset="-120"/>
+                <a:latin typeface="Arial" pitchFamily="34" charset="0"/>
+                <a:ea typeface="Arial" pitchFamily="34" charset="-122"/>
+                <a:cs typeface="Arial" pitchFamily="34" charset="-120"/>
               </a:rPr>
               <a:t>one NFT mint, one dependency chain</a:t>
             </a:r>
@@ -3619,9 +2388,9 @@
                 <a:solidFill>
                   <a:srgbClr val="AEB6C8"/>
                 </a:solidFill>
-                <a:latin typeface="Calibri" pitchFamily="34" charset="0"/>
-                <a:ea typeface="Calibri" pitchFamily="34" charset="-122"/>
-                <a:cs typeface="Calibri" pitchFamily="34" charset="-120"/>
+                <a:latin typeface="Arial" pitchFamily="34" charset="0"/>
+                <a:ea typeface="Arial" pitchFamily="34" charset="-122"/>
+                <a:cs typeface="Arial" pitchFamily="34" charset="-120"/>
               </a:rPr>
               <a:t>Block-STM, 6 performance cores, vs. sequential</a:t>
             </a:r>
@@ -3690,9 +2459,9 @@
                 <a:solidFill>
                   <a:srgbClr val="EB6834"/>
                 </a:solidFill>
-                <a:latin typeface="Calibri" pitchFamily="34" charset="0"/>
-                <a:ea typeface="Calibri" pitchFamily="34" charset="-122"/>
-                <a:cs typeface="Calibri" pitchFamily="34" charset="-120"/>
+                <a:latin typeface="Arial" pitchFamily="34" charset="0"/>
+                <a:ea typeface="Arial" pitchFamily="34" charset="-122"/>
+                <a:cs typeface="Arial" pitchFamily="34" charset="-120"/>
               </a:rPr>
               <a:t>RESULT 4</a:t>
             </a:r>
@@ -3725,17 +2494,17 @@
               <a:buNone/>
             </a:pPr>
             <a:r>
-              <a:rPr lang="en-US" sz="3200" b="1" dirty="0">
+              <a:rPr lang="en-US" sz="2800" b="1" dirty="0">
                 <a:solidFill>
                   <a:srgbClr val="14181F"/>
                 </a:solidFill>
-                <a:latin typeface="Calibri" pitchFamily="34" charset="0"/>
-                <a:ea typeface="Calibri" pitchFamily="34" charset="-122"/>
-                <a:cs typeface="Calibri" pitchFamily="34" charset="-120"/>
+                <a:latin typeface="Arial" pitchFamily="34" charset="0"/>
+                <a:ea typeface="Arial" pitchFamily="34" charset="-122"/>
+                <a:cs typeface="Arial" pitchFamily="34" charset="-120"/>
               </a:rPr>
               <a:t>The scheduler matters as much as the workload</a:t>
             </a:r>
-            <a:endParaRPr lang="en-US" sz="3200" dirty="0"/>
+            <a:endParaRPr lang="en-US" sz="2800" dirty="0"/>
           </a:p>
         </p:txBody>
       </p:sp>
@@ -3792,9 +2561,9 @@
                 <a:solidFill>
                   <a:srgbClr val="2A78D6"/>
                 </a:solidFill>
-                <a:latin typeface="Calibri" pitchFamily="34" charset="0"/>
-                <a:ea typeface="Calibri" pitchFamily="34" charset="-122"/>
-                <a:cs typeface="Calibri" pitchFamily="34" charset="-120"/>
+                <a:latin typeface="Arial" pitchFamily="34" charset="0"/>
+                <a:ea typeface="Arial" pitchFamily="34" charset="-122"/>
+                <a:cs typeface="Arial" pitchFamily="34" charset="-120"/>
               </a:rPr>
               <a:t>247×</a:t>
             </a:r>
@@ -3831,9 +2600,9 @@
                 <a:solidFill>
                   <a:srgbClr val="5A6272"/>
                 </a:solidFill>
-                <a:latin typeface="Calibri" pitchFamily="34" charset="0"/>
-                <a:ea typeface="Calibri" pitchFamily="34" charset="-122"/>
-                <a:cs typeface="Calibri" pitchFamily="34" charset="-120"/>
+                <a:latin typeface="Arial" pitchFamily="34" charset="0"/>
+                <a:ea typeface="Arial" pitchFamily="34" charset="-122"/>
+                <a:cs typeface="Arial" pitchFamily="34" charset="-120"/>
               </a:rPr>
               <a:t>executions per transaction on an NFT mint under round-based execution — speedup 0.01×</a:t>
             </a:r>
@@ -3870,9 +2639,9 @@
                 <a:solidFill>
                   <a:srgbClr val="EB6834"/>
                 </a:solidFill>
-                <a:latin typeface="Calibri" pitchFamily="34" charset="0"/>
-                <a:ea typeface="Calibri" pitchFamily="34" charset="-122"/>
-                <a:cs typeface="Calibri" pitchFamily="34" charset="-120"/>
+                <a:latin typeface="Arial" pitchFamily="34" charset="0"/>
+                <a:ea typeface="Arial" pitchFamily="34" charset="-122"/>
+                <a:cs typeface="Arial" pitchFamily="34" charset="-120"/>
               </a:rPr>
               <a:t>1.9×</a:t>
             </a:r>
@@ -3909,9 +2678,9 @@
                 <a:solidFill>
                   <a:srgbClr val="5A6272"/>
                 </a:solidFill>
-                <a:latin typeface="Calibri" pitchFamily="34" charset="0"/>
-                <a:ea typeface="Calibri" pitchFamily="34" charset="-122"/>
-                <a:cs typeface="Calibri" pitchFamily="34" charset="-120"/>
+                <a:latin typeface="Arial" pitchFamily="34" charset="0"/>
+                <a:ea typeface="Arial" pitchFamily="34" charset="-122"/>
+                <a:cs typeface="Arial" pitchFamily="34" charset="-120"/>
               </a:rPr>
               <a:t>under Block-STM on the same block — parking waiting transactions instead of re-running them</a:t>
             </a:r>
@@ -3948,9 +2717,9 @@
                 <a:solidFill>
                   <a:srgbClr val="5A6272"/>
                 </a:solidFill>
-                <a:latin typeface="Calibri" pitchFamily="34" charset="0"/>
-                <a:ea typeface="Calibri" pitchFamily="34" charset="-122"/>
-                <a:cs typeface="Calibri" pitchFamily="34" charset="-120"/>
+                <a:latin typeface="Arial" pitchFamily="34" charset="0"/>
+                <a:ea typeface="Arial" pitchFamily="34" charset="-122"/>
+                <a:cs typeface="Arial" pitchFamily="34" charset="-120"/>
               </a:rPr>
               <a:t>6 threads. At low density both run each transaction about once.</a:t>
             </a:r>
@@ -4019,9 +2788,9 @@
                 <a:solidFill>
                   <a:srgbClr val="EB6834"/>
                 </a:solidFill>
-                <a:latin typeface="Calibri" pitchFamily="34" charset="0"/>
-                <a:ea typeface="Calibri" pitchFamily="34" charset="-122"/>
-                <a:cs typeface="Calibri" pitchFamily="34" charset="-120"/>
+                <a:latin typeface="Arial" pitchFamily="34" charset="0"/>
+                <a:ea typeface="Arial" pitchFamily="34" charset="-122"/>
+                <a:cs typeface="Arial" pitchFamily="34" charset="-120"/>
               </a:rPr>
               <a:t>RESULT 5</a:t>
             </a:r>
@@ -4054,36 +2823,44 @@
               <a:buNone/>
             </a:pPr>
             <a:r>
-              <a:rPr lang="en-US" sz="3200" b="1" dirty="0">
+              <a:rPr lang="en-US" sz="2800" b="1" dirty="0">
                 <a:solidFill>
                   <a:srgbClr val="14181F"/>
                 </a:solidFill>
-                <a:latin typeface="Calibri" pitchFamily="34" charset="0"/>
-                <a:ea typeface="Calibri" pitchFamily="34" charset="-122"/>
-                <a:cs typeface="Calibri" pitchFamily="34" charset="-120"/>
+                <a:latin typeface="Arial" pitchFamily="34" charset="0"/>
+                <a:ea typeface="Arial" pitchFamily="34" charset="-122"/>
+                <a:cs typeface="Arial" pitchFamily="34" charset="-120"/>
               </a:rPr>
               <a:t>Per-account conflict detection throws ERC-20 parallelism away</a:t>
             </a:r>
-            <a:endParaRPr lang="en-US" sz="3200" dirty="0"/>
-          </a:p>
-        </p:txBody>
-      </p:sp>
-      <p:graphicFrame>
-        <p:nvGraphicFramePr>
-          <p:cNvPr id="4" name="Chart 0" descr=""/>
-          <p:cNvGraphicFramePr/>
-          <p:nvPr/>
-        </p:nvGraphicFramePr>
-        <p:xfrm>
-          <a:off x="548640" y="1371600"/>
-          <a:ext cx="6949440" cy="4754880"/>
-        </p:xfrm>
-        <a:graphic xmlns:a="http://schemas.openxmlformats.org/drawingml/2006/main">
-          <a:graphicData uri="http://schemas.openxmlformats.org/drawingml/2006/chart">
-            <c:chart xmlns:c="http://schemas.openxmlformats.org/drawingml/2006/chart" r:id="rId1"/>
-          </a:graphicData>
-        </a:graphic>
-      </p:graphicFrame>
+            <a:endParaRPr lang="en-US" sz="2800" dirty="0"/>
+          </a:p>
+        </p:txBody>
+      </p:sp>
+      <p:pic>
+        <p:nvPicPr>
+          <p:cNvPr id="4" name="Image 0" descr="/Users/franz/Desktop/SC6109/docs/figures/slide_granularity_erc20.png">    </p:cNvPr>
+          <p:cNvPicPr>
+            <a:picLocks noChangeAspect="1"/>
+          </p:cNvPicPr>
+          <p:nvPr/>
+        </p:nvPicPr>
+        <p:blipFill>
+          <a:blip r:embed="rId1"/>
+          <a:stretch>
+            <a:fillRect/>
+          </a:stretch>
+        </p:blipFill>
+        <p:spPr>
+          <a:xfrm>
+            <a:off x="548640" y="1371600"/>
+            <a:ext cx="6949440" cy="4705105"/>
+          </a:xfrm>
+          <a:prstGeom prst="rect">
+            <a:avLst/>
+          </a:prstGeom>
+        </p:spPr>
+      </p:pic>
       <p:sp>
         <p:nvSpPr>
           <p:cNvPr id="5" name="Text 2"/>
@@ -4116,9 +2893,9 @@
                 <a:solidFill>
                   <a:srgbClr val="14181F"/>
                 </a:solidFill>
-                <a:latin typeface="Calibri" pitchFamily="34" charset="0"/>
-                <a:ea typeface="Calibri" pitchFamily="34" charset="-122"/>
-                <a:cs typeface="Calibri" pitchFamily="34" charset="-120"/>
+                <a:latin typeface="Arial" pitchFamily="34" charset="0"/>
+                <a:ea typeface="Arial" pitchFamily="34" charset="-122"/>
+                <a:cs typeface="Arial" pitchFamily="34" charset="-120"/>
               </a:rPr>
               <a:t>Why</a:t>
             </a:r>
@@ -4158,9 +2935,9 @@
                 <a:solidFill>
                   <a:srgbClr val="14181F"/>
                 </a:solidFill>
-                <a:latin typeface="Calibri" pitchFamily="34" charset="0"/>
-                <a:ea typeface="Calibri" pitchFamily="34" charset="-122"/>
-                <a:cs typeface="Calibri" pitchFamily="34" charset="-120"/>
+                <a:latin typeface="Arial" pitchFamily="34" charset="0"/>
+                <a:ea typeface="Arial" pitchFamily="34" charset="-122"/>
+                <a:cs typeface="Arial" pitchFamily="34" charset="-120"/>
               </a:rPr>
               <a:t>Every ERC-20 balance is a storage slot in the token contract. Per slot, transfers between different holders never collide. Per account, they all collide in one account — the token.</a:t>
             </a:r>
@@ -4200,9 +2977,9 @@
                 <a:solidFill>
                   <a:srgbClr val="14181F"/>
                 </a:solidFill>
-                <a:latin typeface="Calibri" pitchFamily="34" charset="0"/>
-                <a:ea typeface="Calibri" pitchFamily="34" charset="-122"/>
-                <a:cs typeface="Calibri" pitchFamily="34" charset="-120"/>
+                <a:latin typeface="Arial" pitchFamily="34" charset="0"/>
+                <a:ea typeface="Arial" pitchFamily="34" charset="-122"/>
+                <a:cs typeface="Arial" pitchFamily="34" charset="-120"/>
               </a:rPr>
               <a:t>So what</a:t>
             </a:r>
@@ -4242,9 +3019,9 @@
                 <a:solidFill>
                   <a:srgbClr val="14181F"/>
                 </a:solidFill>
-                <a:latin typeface="Calibri" pitchFamily="34" charset="0"/>
-                <a:ea typeface="Calibri" pitchFamily="34" charset="-122"/>
-                <a:cs typeface="Calibri" pitchFamily="34" charset="-120"/>
+                <a:latin typeface="Arial" pitchFamily="34" charset="0"/>
+                <a:ea typeface="Arial" pitchFamily="34" charset="-122"/>
+                <a:cs typeface="Arial" pitchFamily="34" charset="-120"/>
               </a:rPr>
               <a:t>An access-list design is only as good as its granularity. EIP-7928 lists storage keys; an account-level list would not work for contracts. Plain ETH transfers — accounts without storage — are identical under both, as they should be.</a:t>
             </a:r>
@@ -4313,9 +3090,9 @@
                 <a:solidFill>
                   <a:srgbClr val="EB6834"/>
                 </a:solidFill>
-                <a:latin typeface="Calibri" pitchFamily="34" charset="0"/>
-                <a:ea typeface="Calibri" pitchFamily="34" charset="-122"/>
-                <a:cs typeface="Calibri" pitchFamily="34" charset="-120"/>
+                <a:latin typeface="Arial" pitchFamily="34" charset="0"/>
+                <a:ea typeface="Arial" pitchFamily="34" charset="-122"/>
+                <a:cs typeface="Arial" pitchFamily="34" charset="-120"/>
               </a:rPr>
               <a:t>THE ANSWER</a:t>
             </a:r>
@@ -4348,36 +3125,44 @@
               <a:buNone/>
             </a:pPr>
             <a:r>
-              <a:rPr lang="en-US" sz="3200" b="1" dirty="0">
+              <a:rPr lang="en-US" sz="2800" b="1" dirty="0">
                 <a:solidFill>
                   <a:srgbClr val="14181F"/>
                 </a:solidFill>
-                <a:latin typeface="Calibri" pitchFamily="34" charset="0"/>
-                <a:ea typeface="Calibri" pitchFamily="34" charset="-122"/>
-                <a:cs typeface="Calibri" pitchFamily="34" charset="-120"/>
+                <a:latin typeface="Arial" pitchFamily="34" charset="0"/>
+                <a:ea typeface="Arial" pitchFamily="34" charset="-122"/>
+                <a:cs typeface="Arial" pitchFamily="34" charset="-120"/>
               </a:rPr>
               <a:t>Parallel execution pays only when all three hold</a:t>
             </a:r>
-            <a:endParaRPr lang="en-US" sz="3200" dirty="0"/>
-          </a:p>
-        </p:txBody>
-      </p:sp>
-      <p:graphicFrame>
-        <p:nvGraphicFramePr>
-          <p:cNvPr id="4" name="Chart 0" descr=""/>
-          <p:cNvGraphicFramePr/>
-          <p:nvPr/>
-        </p:nvGraphicFramePr>
-        <p:xfrm>
-          <a:off x="548640" y="1371600"/>
-          <a:ext cx="6035040" cy="4663440"/>
-        </p:xfrm>
-        <a:graphic xmlns:a="http://schemas.openxmlformats.org/drawingml/2006/main">
-          <a:graphicData uri="http://schemas.openxmlformats.org/drawingml/2006/chart">
-            <c:chart xmlns:c="http://schemas.openxmlformats.org/drawingml/2006/chart" r:id="rId1"/>
-          </a:graphicData>
-        </a:graphic>
-      </p:graphicFrame>
+            <a:endParaRPr lang="en-US" sz="2800" dirty="0"/>
+          </a:p>
+        </p:txBody>
+      </p:sp>
+      <p:pic>
+        <p:nvPicPr>
+          <p:cNvPr id="4" name="Image 0" descr="/Users/franz/Desktop/SC6109/docs/figures/slide_answer_bars.png">    </p:cNvPr>
+          <p:cNvPicPr>
+            <a:picLocks noChangeAspect="1"/>
+          </p:cNvPicPr>
+          <p:nvPr/>
+        </p:nvPicPr>
+        <p:blipFill>
+          <a:blip r:embed="rId1"/>
+          <a:stretch>
+            <a:fillRect/>
+          </a:stretch>
+        </p:blipFill>
+        <p:spPr>
+          <a:xfrm>
+            <a:off x="548640" y="1417320"/>
+            <a:ext cx="6035040" cy="4613945"/>
+          </a:xfrm>
+          <a:prstGeom prst="rect">
+            <a:avLst/>
+          </a:prstGeom>
+        </p:spPr>
+      </p:pic>
       <p:sp>
         <p:nvSpPr>
           <p:cNvPr id="5" name="Shape 2"/>
@@ -4434,9 +3219,9 @@
                 <a:solidFill>
                   <a:srgbClr val="FFFFFF"/>
                 </a:solidFill>
-                <a:latin typeface="Calibri" pitchFamily="34" charset="0"/>
-                <a:ea typeface="Calibri" pitchFamily="34" charset="-122"/>
-                <a:cs typeface="Calibri" pitchFamily="34" charset="-120"/>
+                <a:latin typeface="Arial" pitchFamily="34" charset="0"/>
+                <a:ea typeface="Arial" pitchFamily="34" charset="-122"/>
+                <a:cs typeface="Arial" pitchFamily="34" charset="-120"/>
               </a:rPr>
               <a:t>1</a:t>
             </a:r>
@@ -4473,9 +3258,9 @@
                 <a:solidFill>
                   <a:srgbClr val="14181F"/>
                 </a:solidFill>
-                <a:latin typeface="Calibri" pitchFamily="34" charset="0"/>
-                <a:ea typeface="Calibri" pitchFamily="34" charset="-122"/>
-                <a:cs typeface="Calibri" pitchFamily="34" charset="-120"/>
+                <a:latin typeface="Arial" pitchFamily="34" charset="0"/>
+                <a:ea typeface="Arial" pitchFamily="34" charset="-122"/>
+                <a:cs typeface="Arial" pitchFamily="34" charset="-120"/>
               </a:rPr>
               <a:t>Short dependency chains</a:t>
             </a:r>
@@ -4515,9 +3300,9 @@
                 <a:solidFill>
                   <a:srgbClr val="5A6272"/>
                 </a:solidFill>
-                <a:latin typeface="Calibri" pitchFamily="34" charset="0"/>
-                <a:ea typeface="Calibri" pitchFamily="34" charset="-122"/>
-                <a:cs typeface="Calibri" pitchFamily="34" charset="-120"/>
+                <a:latin typeface="Arial" pitchFamily="34" charset="0"/>
+                <a:ea typeface="Arial" pitchFamily="34" charset="-122"/>
+                <a:cs typeface="Arial" pitchFamily="34" charset="-120"/>
               </a:rPr>
               <a:t>A hot contract is a ceiling no engine removes — only the application can shard it.</a:t>
             </a:r>
@@ -4581,9 +3366,9 @@
                 <a:solidFill>
                   <a:srgbClr val="FFFFFF"/>
                 </a:solidFill>
-                <a:latin typeface="Calibri" pitchFamily="34" charset="0"/>
-                <a:ea typeface="Calibri" pitchFamily="34" charset="-122"/>
-                <a:cs typeface="Calibri" pitchFamily="34" charset="-120"/>
+                <a:latin typeface="Arial" pitchFamily="34" charset="0"/>
+                <a:ea typeface="Arial" pitchFamily="34" charset="-122"/>
+                <a:cs typeface="Arial" pitchFamily="34" charset="-120"/>
               </a:rPr>
               <a:t>2</a:t>
             </a:r>
@@ -4620,9 +3405,9 @@
                 <a:solidFill>
                   <a:srgbClr val="14181F"/>
                 </a:solidFill>
-                <a:latin typeface="Calibri" pitchFamily="34" charset="0"/>
-                <a:ea typeface="Calibri" pitchFamily="34" charset="-122"/>
-                <a:cs typeface="Calibri" pitchFamily="34" charset="-120"/>
+                <a:latin typeface="Arial" pitchFamily="34" charset="0"/>
+                <a:ea typeface="Arial" pitchFamily="34" charset="-122"/>
+                <a:cs typeface="Arial" pitchFamily="34" charset="-120"/>
               </a:rPr>
               <a:t>Real work per transaction</a:t>
             </a:r>
@@ -4662,9 +3447,9 @@
                 <a:solidFill>
                   <a:srgbClr val="5A6272"/>
                 </a:solidFill>
-                <a:latin typeface="Calibri" pitchFamily="34" charset="0"/>
-                <a:ea typeface="Calibri" pitchFamily="34" charset="-122"/>
-                <a:cs typeface="Calibri" pitchFamily="34" charset="-120"/>
+                <a:latin typeface="Arial" pitchFamily="34" charset="0"/>
+                <a:ea typeface="Arial" pitchFamily="34" charset="-122"/>
+                <a:cs typeface="Arial" pitchFamily="34" charset="-120"/>
               </a:rPr>
               <a:t>Coordination costs a roughly fixed amount; light transactions never earn it back.</a:t>
             </a:r>
@@ -4728,9 +3513,9 @@
                 <a:solidFill>
                   <a:srgbClr val="FFFFFF"/>
                 </a:solidFill>
-                <a:latin typeface="Calibri" pitchFamily="34" charset="0"/>
-                <a:ea typeface="Calibri" pitchFamily="34" charset="-122"/>
-                <a:cs typeface="Calibri" pitchFamily="34" charset="-120"/>
+                <a:latin typeface="Arial" pitchFamily="34" charset="0"/>
+                <a:ea typeface="Arial" pitchFamily="34" charset="-122"/>
+                <a:cs typeface="Arial" pitchFamily="34" charset="-120"/>
               </a:rPr>
               <a:t>3</a:t>
             </a:r>
@@ -4767,9 +3552,9 @@
                 <a:solidFill>
                   <a:srgbClr val="14181F"/>
                 </a:solidFill>
-                <a:latin typeface="Calibri" pitchFamily="34" charset="0"/>
-                <a:ea typeface="Calibri" pitchFamily="34" charset="-122"/>
-                <a:cs typeface="Calibri" pitchFamily="34" charset="-120"/>
+                <a:latin typeface="Arial" pitchFamily="34" charset="0"/>
+                <a:ea typeface="Arial" pitchFamily="34" charset="-122"/>
+                <a:cs typeface="Arial" pitchFamily="34" charset="-120"/>
               </a:rPr>
               <a:t>Fine-grained conflicts, real cores</a:t>
             </a:r>
@@ -4809,9 +3594,9 @@
                 <a:solidFill>
                   <a:srgbClr val="5A6272"/>
                 </a:solidFill>
-                <a:latin typeface="Calibri" pitchFamily="34" charset="0"/>
-                <a:ea typeface="Calibri" pitchFamily="34" charset="-122"/>
-                <a:cs typeface="Calibri" pitchFamily="34" charset="-120"/>
+                <a:latin typeface="Arial" pitchFamily="34" charset="0"/>
+                <a:ea typeface="Arial" pitchFamily="34" charset="-122"/>
+                <a:cs typeface="Arial" pitchFamily="34" charset="-120"/>
               </a:rPr>
               <a:t>Per-slot detection, and no more threads than performance cores for light work.</a:t>
             </a:r>
@@ -4880,9 +3665,9 @@
                 <a:solidFill>
                   <a:srgbClr val="EB6834"/>
                 </a:solidFill>
-                <a:latin typeface="Calibri" pitchFamily="34" charset="0"/>
-                <a:ea typeface="Calibri" pitchFamily="34" charset="-122"/>
-                <a:cs typeface="Calibri" pitchFamily="34" charset="-120"/>
+                <a:latin typeface="Arial" pitchFamily="34" charset="0"/>
+                <a:ea typeface="Arial" pitchFamily="34" charset="-122"/>
+                <a:cs typeface="Arial" pitchFamily="34" charset="-120"/>
               </a:rPr>
               <a:t>IN CONTEXT</a:t>
             </a:r>
@@ -4915,17 +3700,17 @@
               <a:buNone/>
             </a:pPr>
             <a:r>
-              <a:rPr lang="en-US" sz="3200" b="1" dirty="0">
+              <a:rPr lang="en-US" sz="2800" b="1" dirty="0">
                 <a:solidFill>
                   <a:srgbClr val="14181F"/>
                 </a:solidFill>
-                <a:latin typeface="Calibri" pitchFamily="34" charset="0"/>
-                <a:ea typeface="Calibri" pitchFamily="34" charset="-122"/>
-                <a:cs typeface="Calibri" pitchFamily="34" charset="-120"/>
+                <a:latin typeface="Arial" pitchFamily="34" charset="0"/>
+                <a:ea typeface="Arial" pitchFamily="34" charset="-122"/>
+                <a:cs typeface="Arial" pitchFamily="34" charset="-120"/>
               </a:rPr>
               <a:t>How this maps onto production systems</a:t>
             </a:r>
-            <a:endParaRPr lang="en-US" sz="3200" dirty="0"/>
+            <a:endParaRPr lang="en-US" sz="2800" dirty="0"/>
           </a:p>
         </p:txBody>
       </p:sp>
@@ -5010,9 +3795,9 @@
                 <a:solidFill>
                   <a:srgbClr val="14181F"/>
                 </a:solidFill>
-                <a:latin typeface="Calibri" pitchFamily="34" charset="0"/>
-                <a:ea typeface="Calibri" pitchFamily="34" charset="-122"/>
-                <a:cs typeface="Calibri" pitchFamily="34" charset="-120"/>
+                <a:latin typeface="Arial" pitchFamily="34" charset="0"/>
+                <a:ea typeface="Arial" pitchFamily="34" charset="-122"/>
+                <a:cs typeface="Arial" pitchFamily="34" charset="-120"/>
               </a:rPr>
               <a:t>Aptos · Block-STM</a:t>
             </a:r>
@@ -5052,9 +3837,9 @@
                 <a:solidFill>
                   <a:srgbClr val="14181F"/>
                 </a:solidFill>
-                <a:latin typeface="Calibri" pitchFamily="34" charset="0"/>
-                <a:ea typeface="Calibri" pitchFamily="34" charset="-122"/>
-                <a:cs typeface="Calibri" pitchFamily="34" charset="-120"/>
+                <a:latin typeface="Arial" pitchFamily="34" charset="0"/>
+                <a:ea typeface="Arial" pitchFamily="34" charset="-122"/>
+                <a:cs typeface="Arial" pitchFamily="34" charset="-120"/>
               </a:rPr>
               <a:t>Our M2b follows the Block-STM paper on EVM bytecode instead of Move, and shows the same shape: large gains at low contention, graceful degradation, no collapse.</a:t>
             </a:r>
@@ -5143,9 +3928,9 @@
                 <a:solidFill>
                   <a:srgbClr val="14181F"/>
                 </a:solidFill>
-                <a:latin typeface="Calibri" pitchFamily="34" charset="0"/>
-                <a:ea typeface="Calibri" pitchFamily="34" charset="-122"/>
-                <a:cs typeface="Calibri" pitchFamily="34" charset="-120"/>
+                <a:latin typeface="Arial" pitchFamily="34" charset="0"/>
+                <a:ea typeface="Arial" pitchFamily="34" charset="-122"/>
+                <a:cs typeface="Arial" pitchFamily="34" charset="-120"/>
               </a:rPr>
               <a:t>Solana · Sealevel</a:t>
             </a:r>
@@ -5185,9 +3970,9 @@
                 <a:solidFill>
                   <a:srgbClr val="14181F"/>
                 </a:solidFill>
-                <a:latin typeface="Calibri" pitchFamily="34" charset="0"/>
-                <a:ea typeface="Calibri" pitchFamily="34" charset="-122"/>
-                <a:cs typeface="Calibri" pitchFamily="34" charset="-120"/>
+                <a:latin typeface="Arial" pitchFamily="34" charset="0"/>
+                <a:ea typeface="Arial" pitchFamily="34" charset="-122"/>
+                <a:cs typeface="Arial" pitchFamily="34" charset="-120"/>
               </a:rPr>
               <a:t>Transactions declare the accounts they touch. On the EVM that is account-level detection — which our ERC-20 result shows discards most of the parallelism.</a:t>
             </a:r>
@@ -5276,9 +4061,9 @@
                 <a:solidFill>
                   <a:srgbClr val="14181F"/>
                 </a:solidFill>
-                <a:latin typeface="Calibri" pitchFamily="34" charset="0"/>
-                <a:ea typeface="Calibri" pitchFamily="34" charset="-122"/>
-                <a:cs typeface="Calibri" pitchFamily="34" charset="-120"/>
+                <a:latin typeface="Arial" pitchFamily="34" charset="0"/>
+                <a:ea typeface="Arial" pitchFamily="34" charset="-122"/>
+                <a:cs typeface="Arial" pitchFamily="34" charset="-120"/>
               </a:rPr>
               <a:t>Ethereum · EIP-7928</a:t>
             </a:r>
@@ -5318,9 +4103,9 @@
                 <a:solidFill>
                   <a:srgbClr val="14181F"/>
                 </a:solidFill>
-                <a:latin typeface="Calibri" pitchFamily="34" charset="0"/>
-                <a:ea typeface="Calibri" pitchFamily="34" charset="-122"/>
-                <a:cs typeface="Calibri" pitchFamily="34" charset="-120"/>
+                <a:latin typeface="Arial" pitchFamily="34" charset="0"/>
+                <a:ea typeface="Arial" pitchFamily="34" charset="-122"/>
+                <a:cs typeface="Arial" pitchFamily="34" charset="-120"/>
               </a:rPr>
               <a:t>Builders publish block access lists with storage keys, so validators can schedule statically. Our M3 is that validator; its list costs a full execution, paid once by the builder.</a:t>
             </a:r>
@@ -5409,9 +4194,9 @@
                 <a:solidFill>
                   <a:srgbClr val="14181F"/>
                 </a:solidFill>
-                <a:latin typeface="Calibri" pitchFamily="34" charset="0"/>
-                <a:ea typeface="Calibri" pitchFamily="34" charset="-122"/>
-                <a:cs typeface="Calibri" pitchFamily="34" charset="-120"/>
+                <a:latin typeface="Arial" pitchFamily="34" charset="0"/>
+                <a:ea typeface="Arial" pitchFamily="34" charset="-122"/>
+                <a:cs typeface="Arial" pitchFamily="34" charset="-120"/>
               </a:rPr>
               <a:t>ERC-4337 bundles</a:t>
             </a:r>
@@ -5451,9 +4236,9 @@
                 <a:solidFill>
                   <a:srgbClr val="14181F"/>
                 </a:solidFill>
-                <a:latin typeface="Calibri" pitchFamily="34" charset="0"/>
-                <a:ea typeface="Calibri" pitchFamily="34" charset="-122"/>
-                <a:cs typeface="Calibri" pitchFamily="34" charset="-120"/>
+                <a:latin typeface="Arial" pitchFamily="34" charset="0"/>
+                <a:ea typeface="Arial" pitchFamily="34" charset="-122"/>
+                <a:cs typeface="Arial" pitchFamily="34" charset="-120"/>
               </a:rPr>
               <a:t>Many users' operations in one transaction through one EntryPoint — concentrating state, which is the unfavourable case for parallel execution.</a:t>
             </a:r>
@@ -5522,9 +4307,9 @@
                 <a:solidFill>
                   <a:srgbClr val="EB6834"/>
                 </a:solidFill>
-                <a:latin typeface="Calibri" pitchFamily="34" charset="0"/>
-                <a:ea typeface="Calibri" pitchFamily="34" charset="-122"/>
-                <a:cs typeface="Calibri" pitchFamily="34" charset="-120"/>
+                <a:latin typeface="Arial" pitchFamily="34" charset="0"/>
+                <a:ea typeface="Arial" pitchFamily="34" charset="-122"/>
+                <a:cs typeface="Arial" pitchFamily="34" charset="-120"/>
               </a:rPr>
               <a:t>LIMITS AND NEXT STEPS</a:t>
             </a:r>
@@ -5557,17 +4342,17 @@
               <a:buNone/>
             </a:pPr>
             <a:r>
-              <a:rPr lang="en-US" sz="3200" b="1" dirty="0">
+              <a:rPr lang="en-US" sz="2800" b="1" dirty="0">
                 <a:solidFill>
                   <a:srgbClr val="FFFFFF"/>
                 </a:solidFill>
-                <a:latin typeface="Calibri" pitchFamily="34" charset="0"/>
-                <a:ea typeface="Calibri" pitchFamily="34" charset="-122"/>
-                <a:cs typeface="Calibri" pitchFamily="34" charset="-120"/>
+                <a:latin typeface="Arial" pitchFamily="34" charset="0"/>
+                <a:ea typeface="Arial" pitchFamily="34" charset="-122"/>
+                <a:cs typeface="Arial" pitchFamily="34" charset="-120"/>
               </a:rPr>
               <a:t>What we would do next</a:t>
             </a:r>
-            <a:endParaRPr lang="en-US" sz="3200" dirty="0"/>
+            <a:endParaRPr lang="en-US" sz="2800" dirty="0"/>
           </a:p>
         </p:txBody>
       </p:sp>
@@ -5627,9 +4412,9 @@
                 <a:solidFill>
                   <a:srgbClr val="FFFFFF"/>
                 </a:solidFill>
-                <a:latin typeface="Calibri" pitchFamily="34" charset="0"/>
-                <a:ea typeface="Calibri" pitchFamily="34" charset="-122"/>
-                <a:cs typeface="Calibri" pitchFamily="34" charset="-120"/>
+                <a:latin typeface="Arial" pitchFamily="34" charset="0"/>
+                <a:ea typeface="Arial" pitchFamily="34" charset="-122"/>
+                <a:cs typeface="Arial" pitchFamily="34" charset="-120"/>
               </a:rPr>
               <a:t>Replay real mainnet blocks</a:t>
             </a:r>
@@ -5669,9 +4454,9 @@
                 <a:solidFill>
                   <a:srgbClr val="AEB6C8"/>
                 </a:solidFill>
-                <a:latin typeface="Calibri" pitchFamily="34" charset="0"/>
-                <a:ea typeface="Calibri" pitchFamily="34" charset="-122"/>
-                <a:cs typeface="Calibri" pitchFamily="34" charset="-120"/>
+                <a:latin typeface="Arial" pitchFamily="34" charset="0"/>
+                <a:ea typeface="Arial" pitchFamily="34" charset="-122"/>
+                <a:cs typeface="Arial" pitchFamily="34" charset="-120"/>
               </a:rPr>
               <a:t>Our workloads span the conflict and work axes by design; real traffic would show where chains actually sit on them.</a:t>
             </a:r>
@@ -5735,9 +4520,9 @@
                 <a:solidFill>
                   <a:srgbClr val="FFFFFF"/>
                 </a:solidFill>
-                <a:latin typeface="Calibri" pitchFamily="34" charset="0"/>
-                <a:ea typeface="Calibri" pitchFamily="34" charset="-122"/>
-                <a:cs typeface="Calibri" pitchFamily="34" charset="-120"/>
+                <a:latin typeface="Arial" pitchFamily="34" charset="0"/>
+                <a:ea typeface="Arial" pitchFamily="34" charset="-122"/>
+                <a:cs typeface="Arial" pitchFamily="34" charset="-120"/>
               </a:rPr>
               <a:t>A homogeneous machine</a:t>
             </a:r>
@@ -5777,9 +4562,9 @@
                 <a:solidFill>
                   <a:srgbClr val="AEB6C8"/>
                 </a:solidFill>
-                <a:latin typeface="Calibri" pitchFamily="34" charset="0"/>
-                <a:ea typeface="Calibri" pitchFamily="34" charset="-122"/>
-                <a:cs typeface="Calibri" pitchFamily="34" charset="-120"/>
+                <a:latin typeface="Arial" pitchFamily="34" charset="0"/>
+                <a:ea typeface="Arial" pitchFamily="34" charset="-122"/>
+                <a:cs typeface="Arial" pitchFamily="34" charset="-120"/>
               </a:rPr>
               <a:t>Results above six threads mix in efficiency cores; a server CPU would separate the scheduler from the chip.</a:t>
             </a:r>
@@ -5843,9 +4628,9 @@
                 <a:solidFill>
                   <a:srgbClr val="FFFFFF"/>
                 </a:solidFill>
-                <a:latin typeface="Calibri" pitchFamily="34" charset="0"/>
-                <a:ea typeface="Calibri" pitchFamily="34" charset="-122"/>
-                <a:cs typeface="Calibri" pitchFamily="34" charset="-120"/>
+                <a:latin typeface="Arial" pitchFamily="34" charset="0"/>
+                <a:ea typeface="Arial" pitchFamily="34" charset="-122"/>
+                <a:cs typeface="Arial" pitchFamily="34" charset="-120"/>
               </a:rPr>
               <a:t>Emit EIP-7928 lists</a:t>
             </a:r>
@@ -5885,9 +4670,9 @@
                 <a:solidFill>
                   <a:srgbClr val="AEB6C8"/>
                 </a:solidFill>
-                <a:latin typeface="Calibri" pitchFamily="34" charset="0"/>
-                <a:ea typeface="Calibri" pitchFamily="34" charset="-122"/>
-                <a:cs typeface="Calibri" pitchFamily="34" charset="-120"/>
+                <a:latin typeface="Arial" pitchFamily="34" charset="0"/>
+                <a:ea typeface="Arial" pitchFamily="34" charset="-122"/>
+                <a:cs typeface="Arial" pitchFamily="34" charset="-120"/>
               </a:rPr>
               <a:t>Produce canonical block access lists, and measure the builder's side as well as the validator's.</a:t>
             </a:r>
@@ -5924,9 +4709,9 @@
                 <a:solidFill>
                   <a:srgbClr val="FFFFFF"/>
                 </a:solidFill>
-                <a:latin typeface="Calibri" pitchFamily="34" charset="0"/>
-                <a:ea typeface="Calibri" pitchFamily="34" charset="-122"/>
-                <a:cs typeface="Calibri" pitchFamily="34" charset="-120"/>
+                <a:latin typeface="Arial" pitchFamily="34" charset="0"/>
+                <a:ea typeface="Arial" pitchFamily="34" charset="-122"/>
+                <a:cs typeface="Arial" pitchFamily="34" charset="-120"/>
               </a:rPr>
               <a:t>Code, data, figures and the full report: github.com/IcantFind-a-username/sc6109-parallel-evm</a:t>
             </a:r>
@@ -5963,9 +4748,9 @@
                 <a:solidFill>
                   <a:srgbClr val="EB6834"/>
                 </a:solidFill>
-                <a:latin typeface="Calibri" pitchFamily="34" charset="0"/>
-                <a:ea typeface="Calibri" pitchFamily="34" charset="-122"/>
-                <a:cs typeface="Calibri" pitchFamily="34" charset="-120"/>
+                <a:latin typeface="Arial" pitchFamily="34" charset="0"/>
+                <a:ea typeface="Arial" pitchFamily="34" charset="-122"/>
+                <a:cs typeface="Arial" pitchFamily="34" charset="-120"/>
               </a:rPr>
               <a:t>Thank you</a:t>
             </a:r>
@@ -6034,9 +4819,9 @@
                 <a:solidFill>
                   <a:srgbClr val="EB6834"/>
                 </a:solidFill>
-                <a:latin typeface="Calibri" pitchFamily="34" charset="0"/>
-                <a:ea typeface="Calibri" pitchFamily="34" charset="-122"/>
-                <a:cs typeface="Calibri" pitchFamily="34" charset="-120"/>
+                <a:latin typeface="Arial" pitchFamily="34" charset="0"/>
+                <a:ea typeface="Arial" pitchFamily="34" charset="-122"/>
+                <a:cs typeface="Arial" pitchFamily="34" charset="-120"/>
               </a:rPr>
               <a:t>THE QUESTION</a:t>
             </a:r>
@@ -6069,17 +4854,17 @@
               <a:buNone/>
             </a:pPr>
             <a:r>
-              <a:rPr lang="en-US" sz="3200" b="1" dirty="0">
+              <a:rPr lang="en-US" sz="2800" b="1" dirty="0">
                 <a:solidFill>
                   <a:srgbClr val="14181F"/>
                 </a:solidFill>
-                <a:latin typeface="Calibri" pitchFamily="34" charset="0"/>
-                <a:ea typeface="Calibri" pitchFamily="34" charset="-122"/>
-                <a:cs typeface="Calibri" pitchFamily="34" charset="-120"/>
+                <a:latin typeface="Arial" pitchFamily="34" charset="0"/>
+                <a:ea typeface="Arial" pitchFamily="34" charset="-122"/>
+                <a:cs typeface="Arial" pitchFamily="34" charset="-120"/>
               </a:rPr>
               <a:t>The dependency bound says 1,000×. We measured 1.4×.</a:t>
             </a:r>
-            <a:endParaRPr lang="en-US" sz="3200" dirty="0"/>
+            <a:endParaRPr lang="en-US" sz="2800" dirty="0"/>
           </a:p>
         </p:txBody>
       </p:sp>
@@ -6115,9 +4900,9 @@
                 <a:solidFill>
                   <a:srgbClr val="14181F"/>
                 </a:solidFill>
-                <a:latin typeface="Calibri" pitchFamily="34" charset="0"/>
-                <a:ea typeface="Calibri" pitchFamily="34" charset="-122"/>
-                <a:cs typeface="Calibri" pitchFamily="34" charset="-120"/>
+                <a:latin typeface="Arial" pitchFamily="34" charset="0"/>
+                <a:ea typeface="Arial" pitchFamily="34" charset="-122"/>
+                <a:cs typeface="Arial" pitchFamily="34" charset="-120"/>
               </a:rPr>
               <a:t>Take 2,000 ETH transfers between random accounts in a large population. Almost none of them touch the same account: the longest chain of dependencies is two transactions long, so in principle they could run a thousand ways in parallel.</a:t>
             </a:r>
@@ -6144,9 +4929,9 @@
                 <a:solidFill>
                   <a:srgbClr val="14181F"/>
                 </a:solidFill>
-                <a:latin typeface="Calibri" pitchFamily="34" charset="0"/>
-                <a:ea typeface="Calibri" pitchFamily="34" charset="-122"/>
-                <a:cs typeface="Calibri" pitchFamily="34" charset="-120"/>
+                <a:latin typeface="Arial" pitchFamily="34" charset="0"/>
+                <a:ea typeface="Arial" pitchFamily="34" charset="-122"/>
+                <a:cs typeface="Arial" pitchFamily="34" charset="-120"/>
               </a:rPr>
               <a:t>On six cores, Block-STM runs that block 1.4 times faster than sequential. It runs a block of ERC-20 transfers 2.8 times faster, compute-heavy calls 5.6 times faster — and an NFT mint at less than half speed.</a:t>
             </a:r>
@@ -6173,9 +4958,9 @@
                 <a:solidFill>
                   <a:srgbClr val="14181F"/>
                 </a:solidFill>
-                <a:latin typeface="Calibri" pitchFamily="34" charset="0"/>
-                <a:ea typeface="Calibri" pitchFamily="34" charset="-122"/>
-                <a:cs typeface="Calibri" pitchFamily="34" charset="-120"/>
+                <a:latin typeface="Arial" pitchFamily="34" charset="0"/>
+                <a:ea typeface="Arial" pitchFamily="34" charset="-122"/>
+                <a:cs typeface="Arial" pitchFamily="34" charset="-120"/>
               </a:rPr>
               <a:t>The gap between the bound and the measurement is the subject of this project.</a:t>
             </a:r>
@@ -6239,9 +5024,9 @@
                 <a:solidFill>
                   <a:srgbClr val="5A6272"/>
                 </a:solidFill>
-                <a:latin typeface="Calibri" pitchFamily="34" charset="0"/>
-                <a:ea typeface="Calibri" pitchFamily="34" charset="-122"/>
-                <a:cs typeface="Calibri" pitchFamily="34" charset="-120"/>
+                <a:latin typeface="Arial" pitchFamily="34" charset="0"/>
+                <a:ea typeface="Arial" pitchFamily="34" charset="-122"/>
+                <a:cs typeface="Arial" pitchFamily="34" charset="-120"/>
               </a:rPr>
               <a:t>1,000×</a:t>
             </a:r>
@@ -6278,9 +5063,9 @@
                 <a:solidFill>
                   <a:srgbClr val="14181F"/>
                 </a:solidFill>
-                <a:latin typeface="Calibri" pitchFamily="34" charset="0"/>
-                <a:ea typeface="Calibri" pitchFamily="34" charset="-122"/>
-                <a:cs typeface="Calibri" pitchFamily="34" charset="-120"/>
+                <a:latin typeface="Arial" pitchFamily="34" charset="0"/>
+                <a:ea typeface="Arial" pitchFamily="34" charset="-122"/>
+                <a:cs typeface="Arial" pitchFamily="34" charset="-120"/>
               </a:rPr>
               <a:t>dependency ceiling for independent transfers</a:t>
             </a:r>
@@ -6344,9 +5129,9 @@
                 <a:solidFill>
                   <a:srgbClr val="2A78D6"/>
                 </a:solidFill>
-                <a:latin typeface="Calibri" pitchFamily="34" charset="0"/>
-                <a:ea typeface="Calibri" pitchFamily="34" charset="-122"/>
-                <a:cs typeface="Calibri" pitchFamily="34" charset="-120"/>
+                <a:latin typeface="Arial" pitchFamily="34" charset="0"/>
+                <a:ea typeface="Arial" pitchFamily="34" charset="-122"/>
+                <a:cs typeface="Arial" pitchFamily="34" charset="-120"/>
               </a:rPr>
               <a:t>1.4×</a:t>
             </a:r>
@@ -6383,9 +5168,9 @@
                 <a:solidFill>
                   <a:srgbClr val="14181F"/>
                 </a:solidFill>
-                <a:latin typeface="Calibri" pitchFamily="34" charset="0"/>
-                <a:ea typeface="Calibri" pitchFamily="34" charset="-122"/>
-                <a:cs typeface="Calibri" pitchFamily="34" charset="-120"/>
+                <a:latin typeface="Arial" pitchFamily="34" charset="0"/>
+                <a:ea typeface="Arial" pitchFamily="34" charset="-122"/>
+                <a:cs typeface="Arial" pitchFamily="34" charset="-120"/>
               </a:rPr>
               <a:t>measured, ETH transfers</a:t>
             </a:r>
@@ -6449,9 +5234,9 @@
                 <a:solidFill>
                   <a:srgbClr val="1BAF7A"/>
                 </a:solidFill>
-                <a:latin typeface="Calibri" pitchFamily="34" charset="0"/>
-                <a:ea typeface="Calibri" pitchFamily="34" charset="-122"/>
-                <a:cs typeface="Calibri" pitchFamily="34" charset="-120"/>
+                <a:latin typeface="Arial" pitchFamily="34" charset="0"/>
+                <a:ea typeface="Arial" pitchFamily="34" charset="-122"/>
+                <a:cs typeface="Arial" pitchFamily="34" charset="-120"/>
               </a:rPr>
               <a:t>2.8×</a:t>
             </a:r>
@@ -6488,9 +5273,9 @@
                 <a:solidFill>
                   <a:srgbClr val="14181F"/>
                 </a:solidFill>
-                <a:latin typeface="Calibri" pitchFamily="34" charset="0"/>
-                <a:ea typeface="Calibri" pitchFamily="34" charset="-122"/>
-                <a:cs typeface="Calibri" pitchFamily="34" charset="-120"/>
+                <a:latin typeface="Arial" pitchFamily="34" charset="0"/>
+                <a:ea typeface="Arial" pitchFamily="34" charset="-122"/>
+                <a:cs typeface="Arial" pitchFamily="34" charset="-120"/>
               </a:rPr>
               <a:t>measured, ERC-20 transfers</a:t>
             </a:r>
@@ -6554,9 +5339,9 @@
                 <a:solidFill>
                   <a:srgbClr val="EB6834"/>
                 </a:solidFill>
-                <a:latin typeface="Calibri" pitchFamily="34" charset="0"/>
-                <a:ea typeface="Calibri" pitchFamily="34" charset="-122"/>
-                <a:cs typeface="Calibri" pitchFamily="34" charset="-120"/>
+                <a:latin typeface="Arial" pitchFamily="34" charset="0"/>
+                <a:ea typeface="Arial" pitchFamily="34" charset="-122"/>
+                <a:cs typeface="Arial" pitchFamily="34" charset="-120"/>
               </a:rPr>
               <a:t>0.43×</a:t>
             </a:r>
@@ -6593,9 +5378,9 @@
                 <a:solidFill>
                   <a:srgbClr val="14181F"/>
                 </a:solidFill>
-                <a:latin typeface="Calibri" pitchFamily="34" charset="0"/>
-                <a:ea typeface="Calibri" pitchFamily="34" charset="-122"/>
-                <a:cs typeface="Calibri" pitchFamily="34" charset="-120"/>
+                <a:latin typeface="Arial" pitchFamily="34" charset="0"/>
+                <a:ea typeface="Arial" pitchFamily="34" charset="-122"/>
+                <a:cs typeface="Arial" pitchFamily="34" charset="-120"/>
               </a:rPr>
               <a:t>measured, NFT mint</a:t>
             </a:r>
@@ -6632,9 +5417,9 @@
                 <a:solidFill>
                   <a:srgbClr val="5A6272"/>
                 </a:solidFill>
-                <a:latin typeface="Calibri" pitchFamily="34" charset="0"/>
-                <a:ea typeface="Calibri" pitchFamily="34" charset="-122"/>
-                <a:cs typeface="Calibri" pitchFamily="34" charset="-120"/>
+                <a:latin typeface="Arial" pitchFamily="34" charset="0"/>
+                <a:ea typeface="Arial" pitchFamily="34" charset="-122"/>
+                <a:cs typeface="Arial" pitchFamily="34" charset="-120"/>
               </a:rPr>
               <a:t>Block-STM at 6 threads on an Apple M3 Pro, 2,000-transaction blocks. Ceiling = block size ÷ critical path.</a:t>
             </a:r>
@@ -6703,9 +5488,9 @@
                 <a:solidFill>
                   <a:srgbClr val="EB6834"/>
                 </a:solidFill>
-                <a:latin typeface="Calibri" pitchFamily="34" charset="0"/>
-                <a:ea typeface="Calibri" pitchFamily="34" charset="-122"/>
-                <a:cs typeface="Calibri" pitchFamily="34" charset="-120"/>
+                <a:latin typeface="Arial" pitchFamily="34" charset="0"/>
+                <a:ea typeface="Arial" pitchFamily="34" charset="-122"/>
+                <a:cs typeface="Arial" pitchFamily="34" charset="-120"/>
               </a:rPr>
               <a:t>WHAT WE BUILT</a:t>
             </a:r>
@@ -6738,17 +5523,17 @@
               <a:buNone/>
             </a:pPr>
             <a:r>
-              <a:rPr lang="en-US" sz="3200" b="1" dirty="0">
+              <a:rPr lang="en-US" sz="2800" b="1" dirty="0">
                 <a:solidFill>
                   <a:srgbClr val="14181F"/>
                 </a:solidFill>
-                <a:latin typeface="Calibri" pitchFamily="34" charset="0"/>
-                <a:ea typeface="Calibri" pitchFamily="34" charset="-122"/>
-                <a:cs typeface="Calibri" pitchFamily="34" charset="-120"/>
+                <a:latin typeface="Arial" pitchFamily="34" charset="0"/>
+                <a:ea typeface="Arial" pitchFamily="34" charset="-122"/>
+                <a:cs typeface="Arial" pitchFamily="34" charset="-120"/>
               </a:rPr>
               <a:t>One execution path, three schedulers, every read recorded</a:t>
             </a:r>
-            <a:endParaRPr lang="en-US" sz="3200" dirty="0"/>
+            <a:endParaRPr lang="en-US" sz="2800" dirty="0"/>
           </a:p>
         </p:txBody>
       </p:sp>
@@ -6808,9 +5593,9 @@
                 <a:solidFill>
                   <a:srgbClr val="FFFFFF"/>
                 </a:solidFill>
-                <a:latin typeface="Calibri" pitchFamily="34" charset="0"/>
-                <a:ea typeface="Calibri" pitchFamily="34" charset="-122"/>
-                <a:cs typeface="Calibri" pitchFamily="34" charset="-120"/>
+                <a:latin typeface="Arial" pitchFamily="34" charset="0"/>
+                <a:ea typeface="Arial" pitchFamily="34" charset="-122"/>
+                <a:cs typeface="Arial" pitchFamily="34" charset="-120"/>
               </a:rPr>
               <a:t>revm 41</a:t>
             </a:r>
@@ -6847,9 +5632,9 @@
                 <a:solidFill>
                   <a:srgbClr val="14181F"/>
                 </a:solidFill>
-                <a:latin typeface="Calibri" pitchFamily="34" charset="0"/>
-                <a:ea typeface="Calibri" pitchFamily="34" charset="-122"/>
-                <a:cs typeface="Calibri" pitchFamily="34" charset="-120"/>
+                <a:latin typeface="Arial" pitchFamily="34" charset="0"/>
+                <a:ea typeface="Arial" pitchFamily="34" charset="-122"/>
+                <a:cs typeface="Arial" pitchFamily="34" charset="-120"/>
               </a:rPr>
               <a:t>real EVM, embedded as a library</a:t>
             </a:r>
@@ -6936,9 +5721,9 @@
                 <a:solidFill>
                   <a:srgbClr val="FFFFFF"/>
                 </a:solidFill>
-                <a:latin typeface="Calibri" pitchFamily="34" charset="0"/>
-                <a:ea typeface="Calibri" pitchFamily="34" charset="-122"/>
-                <a:cs typeface="Calibri" pitchFamily="34" charset="-120"/>
+                <a:latin typeface="Arial" pitchFamily="34" charset="0"/>
+                <a:ea typeface="Arial" pitchFamily="34" charset="-122"/>
+                <a:cs typeface="Arial" pitchFamily="34" charset="-120"/>
               </a:rPr>
               <a:t>ReadRecorder</a:t>
             </a:r>
@@ -6975,9 +5760,9 @@
                 <a:solidFill>
                   <a:srgbClr val="14181F"/>
                 </a:solidFill>
-                <a:latin typeface="Calibri" pitchFamily="34" charset="0"/>
-                <a:ea typeface="Calibri" pitchFamily="34" charset="-122"/>
-                <a:cs typeface="Calibri" pitchFamily="34" charset="-120"/>
+                <a:latin typeface="Arial" pitchFamily="34" charset="0"/>
+                <a:ea typeface="Arial" pitchFamily="34" charset="-122"/>
+                <a:cs typeface="Arial" pitchFamily="34" charset="-120"/>
               </a:rPr>
               <a:t>the only DatabaseRef in the crate — no read reaches the EVM unlogged</a:t>
             </a:r>
@@ -7064,9 +5849,9 @@
                 <a:solidFill>
                   <a:srgbClr val="FFFFFF"/>
                 </a:solidFill>
-                <a:latin typeface="Calibri" pitchFamily="34" charset="0"/>
-                <a:ea typeface="Calibri" pitchFamily="34" charset="-122"/>
-                <a:cs typeface="Calibri" pitchFamily="34" charset="-120"/>
+                <a:latin typeface="Arial" pitchFamily="34" charset="0"/>
+                <a:ea typeface="Arial" pitchFamily="34" charset="-122"/>
+                <a:cs typeface="Arial" pitchFamily="34" charset="-120"/>
               </a:rPr>
               <a:t>MVView  ·  SimpleView</a:t>
             </a:r>
@@ -7103,9 +5888,9 @@
                 <a:solidFill>
                   <a:srgbClr val="14181F"/>
                 </a:solidFill>
-                <a:latin typeface="Calibri" pitchFamily="34" charset="0"/>
-                <a:ea typeface="Calibri" pitchFamily="34" charset="-122"/>
-                <a:cs typeface="Calibri" pitchFamily="34" charset="-120"/>
+                <a:latin typeface="Arial" pitchFamily="34" charset="0"/>
+                <a:ea typeface="Arial" pitchFamily="34" charset="-122"/>
+                <a:cs typeface="Arial" pitchFamily="34" charset="-120"/>
               </a:rPr>
               <a:t>multi-version memory for the parallel engines · plain state for the baseline</a:t>
             </a:r>
@@ -7192,9 +5977,9 @@
                 <a:solidFill>
                   <a:srgbClr val="FFFFFF"/>
                 </a:solidFill>
-                <a:latin typeface="Calibri" pitchFamily="34" charset="0"/>
-                <a:ea typeface="Calibri" pitchFamily="34" charset="-122"/>
-                <a:cs typeface="Calibri" pitchFamily="34" charset="-120"/>
+                <a:latin typeface="Arial" pitchFamily="34" charset="0"/>
+                <a:ea typeface="Arial" pitchFamily="34" charset="-122"/>
+                <a:cs typeface="Arial" pitchFamily="34" charset="-120"/>
               </a:rPr>
               <a:t>BaseState</a:t>
             </a:r>
@@ -7231,9 +6016,9 @@
                 <a:solidFill>
                   <a:srgbClr val="14181F"/>
                 </a:solidFill>
-                <a:latin typeface="Calibri" pitchFamily="34" charset="0"/>
-                <a:ea typeface="Calibri" pitchFamily="34" charset="-122"/>
-                <a:cs typeface="Calibri" pitchFamily="34" charset="-120"/>
+                <a:latin typeface="Arial" pitchFamily="34" charset="0"/>
+                <a:ea typeface="Arial" pitchFamily="34" charset="-122"/>
+                <a:cs typeface="Arial" pitchFamily="34" charset="-120"/>
               </a:rPr>
               <a:t>pre-block snapshot: accounts, storage, compiled contract code</a:t>
             </a:r>
@@ -7300,9 +6085,9 @@
                 <a:solidFill>
                   <a:srgbClr val="14181F"/>
                 </a:solidFill>
-                <a:latin typeface="Calibri" pitchFamily="34" charset="0"/>
-                <a:ea typeface="Calibri" pitchFamily="34" charset="-122"/>
-                <a:cs typeface="Calibri" pitchFamily="34" charset="-120"/>
+                <a:latin typeface="Arial" pitchFamily="34" charset="0"/>
+                <a:ea typeface="Arial" pitchFamily="34" charset="-122"/>
+                <a:cs typeface="Arial" pitchFamily="34" charset="-120"/>
               </a:rPr>
               <a:t>Why it is shaped this way</a:t>
             </a:r>
@@ -7342,9 +6127,9 @@
                 <a:solidFill>
                   <a:srgbClr val="14181F"/>
                 </a:solidFill>
-                <a:latin typeface="Calibri" pitchFamily="34" charset="0"/>
-                <a:ea typeface="Calibri" pitchFamily="34" charset="-122"/>
-                <a:cs typeface="Calibri" pitchFamily="34" charset="-120"/>
+                <a:latin typeface="Arial" pitchFamily="34" charset="0"/>
+                <a:ea typeface="Arial" pitchFamily="34" charset="-122"/>
+                <a:cs typeface="Arial" pitchFamily="34" charset="-120"/>
               </a:rPr>
               <a:t>Block-STM is only correct if every read is re-checked. A read the recorder misses is a silent bug that appears on one seed in hundreds.</a:t>
             </a:r>
@@ -7371,9 +6156,9 @@
                 <a:solidFill>
                   <a:srgbClr val="14181F"/>
                 </a:solidFill>
-                <a:latin typeface="Calibri" pitchFamily="34" charset="0"/>
-                <a:ea typeface="Calibri" pitchFamily="34" charset="-122"/>
-                <a:cs typeface="Calibri" pitchFamily="34" charset="-120"/>
+                <a:latin typeface="Arial" pitchFamily="34" charset="0"/>
+                <a:ea typeface="Arial" pitchFamily="34" charset="-122"/>
+                <a:cs typeface="Arial" pitchFamily="34" charset="-120"/>
               </a:rPr>
               <a:t>So reads are captured in one place, by construction — and the sequential baseline goes through the same path, so it is never quietly cheaper than what it is compared against.</a:t>
             </a:r>
@@ -7410,9 +6195,9 @@
                 <a:solidFill>
                   <a:srgbClr val="5A6272"/>
                 </a:solidFill>
-                <a:latin typeface="Calibri" pitchFamily="34" charset="0"/>
-                <a:ea typeface="Calibri" pitchFamily="34" charset="-122"/>
-                <a:cs typeface="Calibri" pitchFamily="34" charset="-120"/>
+                <a:latin typeface="Arial" pitchFamily="34" charset="0"/>
+                <a:ea typeface="Arial" pitchFamily="34" charset="-122"/>
+                <a:cs typeface="Arial" pitchFamily="34" charset="-120"/>
               </a:rPr>
               <a:t>Rust · revm 41.0.0 · rayon · Solidity 0.8.28 via Foundry</a:t>
             </a:r>
@@ -7481,9 +6266,9 @@
                 <a:solidFill>
                   <a:srgbClr val="EB6834"/>
                 </a:solidFill>
-                <a:latin typeface="Calibri" pitchFamily="34" charset="0"/>
-                <a:ea typeface="Calibri" pitchFamily="34" charset="-122"/>
-                <a:cs typeface="Calibri" pitchFamily="34" charset="-120"/>
+                <a:latin typeface="Arial" pitchFamily="34" charset="0"/>
+                <a:ea typeface="Arial" pitchFamily="34" charset="-122"/>
+                <a:cs typeface="Arial" pitchFamily="34" charset="-120"/>
               </a:rPr>
               <a:t>THREE WAYS TO FIND PARALLELISM</a:t>
             </a:r>
@@ -7516,17 +6301,17 @@
               <a:buNone/>
             </a:pPr>
             <a:r>
-              <a:rPr lang="en-US" sz="3200" b="1" dirty="0">
+              <a:rPr lang="en-US" sz="2800" b="1" dirty="0">
                 <a:solidFill>
                   <a:srgbClr val="14181F"/>
                 </a:solidFill>
-                <a:latin typeface="Calibri" pitchFamily="34" charset="0"/>
-                <a:ea typeface="Calibri" pitchFamily="34" charset="-122"/>
-                <a:cs typeface="Calibri" pitchFamily="34" charset="-120"/>
+                <a:latin typeface="Arial" pitchFamily="34" charset="0"/>
+                <a:ea typeface="Arial" pitchFamily="34" charset="-122"/>
+                <a:cs typeface="Arial" pitchFamily="34" charset="-120"/>
               </a:rPr>
               <a:t>Speculate in rounds, collaborate, or declare up front</a:t>
             </a:r>
-            <a:endParaRPr lang="en-US" sz="3200" dirty="0"/>
+            <a:endParaRPr lang="en-US" sz="2800" dirty="0"/>
           </a:p>
         </p:txBody>
       </p:sp>
@@ -7613,9 +6398,9 @@
                 <a:solidFill>
                   <a:srgbClr val="FFFFFF"/>
                 </a:solidFill>
-                <a:latin typeface="Calibri" pitchFamily="34" charset="0"/>
-                <a:ea typeface="Calibri" pitchFamily="34" charset="-122"/>
-                <a:cs typeface="Calibri" pitchFamily="34" charset="-120"/>
+                <a:latin typeface="Arial" pitchFamily="34" charset="0"/>
+                <a:ea typeface="Arial" pitchFamily="34" charset="-122"/>
+                <a:cs typeface="Arial" pitchFamily="34" charset="-120"/>
               </a:rPr>
               <a:t>1</a:t>
             </a:r>
@@ -7652,9 +6437,9 @@
                 <a:solidFill>
                   <a:srgbClr val="5A6272"/>
                 </a:solidFill>
-                <a:latin typeface="Calibri" pitchFamily="34" charset="0"/>
-                <a:ea typeface="Calibri" pitchFamily="34" charset="-122"/>
-                <a:cs typeface="Calibri" pitchFamily="34" charset="-120"/>
+                <a:latin typeface="Arial" pitchFamily="34" charset="0"/>
+                <a:ea typeface="Arial" pitchFamily="34" charset="-122"/>
+                <a:cs typeface="Arial" pitchFamily="34" charset="-120"/>
               </a:rPr>
               <a:t>M2a</a:t>
             </a:r>
@@ -7691,9 +6476,9 @@
                 <a:solidFill>
                   <a:srgbClr val="14181F"/>
                 </a:solidFill>
-                <a:latin typeface="Calibri" pitchFamily="34" charset="0"/>
-                <a:ea typeface="Calibri" pitchFamily="34" charset="-122"/>
-                <a:cs typeface="Calibri" pitchFamily="34" charset="-120"/>
+                <a:latin typeface="Arial" pitchFamily="34" charset="0"/>
+                <a:ea typeface="Arial" pitchFamily="34" charset="-122"/>
+                <a:cs typeface="Arial" pitchFamily="34" charset="-120"/>
               </a:rPr>
               <a:t>Round-based optimistic</a:t>
             </a:r>
@@ -7733,9 +6518,9 @@
                 <a:solidFill>
                   <a:srgbClr val="14181F"/>
                 </a:solidFill>
-                <a:latin typeface="Calibri" pitchFamily="34" charset="0"/>
-                <a:ea typeface="Calibri" pitchFamily="34" charset="-122"/>
-                <a:cs typeface="Calibri" pitchFamily="34" charset="-120"/>
+                <a:latin typeface="Arial" pitchFamily="34" charset="0"/>
+                <a:ea typeface="Arial" pitchFamily="34" charset="-122"/>
+                <a:cs typeface="Arial" pitchFamily="34" charset="-120"/>
               </a:rPr>
               <a:t>Run every pending transaction at once, validate all, re-run the failures, repeat.</a:t>
             </a:r>
@@ -7775,9 +6560,9 @@
                 <a:solidFill>
                   <a:srgbClr val="14181F"/>
                 </a:solidFill>
-                <a:latin typeface="Calibri" pitchFamily="34" charset="0"/>
-                <a:ea typeface="Calibri" pitchFamily="34" charset="-122"/>
-                <a:cs typeface="Calibri" pitchFamily="34" charset="-120"/>
+                <a:latin typeface="Arial" pitchFamily="34" charset="0"/>
+                <a:ea typeface="Arial" pitchFamily="34" charset="-122"/>
+                <a:cs typeface="Arial" pitchFamily="34" charset="-120"/>
               </a:rPr>
               <a:t>+ Simple; provably ends within n rounds.</a:t>
             </a:r>
@@ -7817,9 +6602,9 @@
                 <a:solidFill>
                   <a:srgbClr val="5A6272"/>
                 </a:solidFill>
-                <a:latin typeface="Calibri" pitchFamily="34" charset="0"/>
-                <a:ea typeface="Calibri" pitchFamily="34" charset="-122"/>
-                <a:cs typeface="Calibri" pitchFamily="34" charset="-120"/>
+                <a:latin typeface="Arial" pitchFamily="34" charset="0"/>
+                <a:ea typeface="Arial" pitchFamily="34" charset="-122"/>
+                <a:cs typeface="Arial" pitchFamily="34" charset="-120"/>
               </a:rPr>
               <a:t>− On a dependency chain, re-runs everything above each fix: quadratic.</a:t>
             </a:r>
@@ -7910,9 +6695,9 @@
                 <a:solidFill>
                   <a:srgbClr val="FFFFFF"/>
                 </a:solidFill>
-                <a:latin typeface="Calibri" pitchFamily="34" charset="0"/>
-                <a:ea typeface="Calibri" pitchFamily="34" charset="-122"/>
-                <a:cs typeface="Calibri" pitchFamily="34" charset="-120"/>
+                <a:latin typeface="Arial" pitchFamily="34" charset="0"/>
+                <a:ea typeface="Arial" pitchFamily="34" charset="-122"/>
+                <a:cs typeface="Arial" pitchFamily="34" charset="-120"/>
               </a:rPr>
               <a:t>2</a:t>
             </a:r>
@@ -7949,9 +6734,9 @@
                 <a:solidFill>
                   <a:srgbClr val="5A6272"/>
                 </a:solidFill>
-                <a:latin typeface="Calibri" pitchFamily="34" charset="0"/>
-                <a:ea typeface="Calibri" pitchFamily="34" charset="-122"/>
-                <a:cs typeface="Calibri" pitchFamily="34" charset="-120"/>
+                <a:latin typeface="Arial" pitchFamily="34" charset="0"/>
+                <a:ea typeface="Arial" pitchFamily="34" charset="-122"/>
+                <a:cs typeface="Arial" pitchFamily="34" charset="-120"/>
               </a:rPr>
               <a:t>M2b</a:t>
             </a:r>
@@ -7988,9 +6773,9 @@
                 <a:solidFill>
                   <a:srgbClr val="14181F"/>
                 </a:solidFill>
-                <a:latin typeface="Calibri" pitchFamily="34" charset="0"/>
-                <a:ea typeface="Calibri" pitchFamily="34" charset="-122"/>
-                <a:cs typeface="Calibri" pitchFamily="34" charset="-120"/>
+                <a:latin typeface="Arial" pitchFamily="34" charset="0"/>
+                <a:ea typeface="Arial" pitchFamily="34" charset="-122"/>
+                <a:cs typeface="Arial" pitchFamily="34" charset="-120"/>
               </a:rPr>
               <a:t>Block-STM</a:t>
             </a:r>
@@ -8030,9 +6815,9 @@
                 <a:solidFill>
                   <a:srgbClr val="14181F"/>
                 </a:solidFill>
-                <a:latin typeface="Calibri" pitchFamily="34" charset="0"/>
-                <a:ea typeface="Calibri" pitchFamily="34" charset="-122"/>
-                <a:cs typeface="Calibri" pitchFamily="34" charset="-120"/>
+                <a:latin typeface="Arial" pitchFamily="34" charset="0"/>
+                <a:ea typeface="Arial" pitchFamily="34" charset="-122"/>
+                <a:cs typeface="Arial" pitchFamily="34" charset="-120"/>
               </a:rPr>
               <a:t>Workers share execution and validation tasks; a read of an aborted write parks the reader until the writer finishes.</a:t>
             </a:r>
@@ -8072,9 +6857,9 @@
                 <a:solidFill>
                   <a:srgbClr val="14181F"/>
                 </a:solidFill>
-                <a:latin typeface="Calibri" pitchFamily="34" charset="0"/>
-                <a:ea typeface="Calibri" pitchFamily="34" charset="-122"/>
-                <a:cs typeface="Calibri" pitchFamily="34" charset="-120"/>
+                <a:latin typeface="Arial" pitchFamily="34" charset="0"/>
+                <a:ea typeface="Arial" pitchFamily="34" charset="-122"/>
+                <a:cs typeface="Arial" pitchFamily="34" charset="-120"/>
               </a:rPr>
               <a:t>+ Degrades gracefully under contention.</a:t>
             </a:r>
@@ -8114,9 +6899,9 @@
                 <a:solidFill>
                   <a:srgbClr val="5A6272"/>
                 </a:solidFill>
-                <a:latin typeface="Calibri" pitchFamily="34" charset="0"/>
-                <a:ea typeface="Calibri" pitchFamily="34" charset="-122"/>
-                <a:cs typeface="Calibri" pitchFamily="34" charset="-120"/>
+                <a:latin typeface="Arial" pitchFamily="34" charset="0"/>
+                <a:ea typeface="Arial" pitchFamily="34" charset="-122"/>
+                <a:cs typeface="Arial" pitchFamily="34" charset="-120"/>
               </a:rPr>
               <a:t>− Pays for versioning and validation even when nothing conflicts.</a:t>
             </a:r>
@@ -8207,9 +6992,9 @@
                 <a:solidFill>
                   <a:srgbClr val="FFFFFF"/>
                 </a:solidFill>
-                <a:latin typeface="Calibri" pitchFamily="34" charset="0"/>
-                <a:ea typeface="Calibri" pitchFamily="34" charset="-122"/>
-                <a:cs typeface="Calibri" pitchFamily="34" charset="-120"/>
+                <a:latin typeface="Arial" pitchFamily="34" charset="0"/>
+                <a:ea typeface="Arial" pitchFamily="34" charset="-122"/>
+                <a:cs typeface="Arial" pitchFamily="34" charset="-120"/>
               </a:rPr>
               <a:t>3</a:t>
             </a:r>
@@ -8246,9 +7031,9 @@
                 <a:solidFill>
                   <a:srgbClr val="5A6272"/>
                 </a:solidFill>
-                <a:latin typeface="Calibri" pitchFamily="34" charset="0"/>
-                <a:ea typeface="Calibri" pitchFamily="34" charset="-122"/>
-                <a:cs typeface="Calibri" pitchFamily="34" charset="-120"/>
+                <a:latin typeface="Arial" pitchFamily="34" charset="0"/>
+                <a:ea typeface="Arial" pitchFamily="34" charset="-122"/>
+                <a:cs typeface="Arial" pitchFamily="34" charset="-120"/>
               </a:rPr>
               <a:t>M3</a:t>
             </a:r>
@@ -8285,9 +7070,9 @@
                 <a:solidFill>
                   <a:srgbClr val="14181F"/>
                 </a:solidFill>
-                <a:latin typeface="Calibri" pitchFamily="34" charset="0"/>
-                <a:ea typeface="Calibri" pitchFamily="34" charset="-122"/>
-                <a:cs typeface="Calibri" pitchFamily="34" charset="-120"/>
+                <a:latin typeface="Arial" pitchFamily="34" charset="0"/>
+                <a:ea typeface="Arial" pitchFamily="34" charset="-122"/>
+                <a:cs typeface="Arial" pitchFamily="34" charset="-120"/>
               </a:rPr>
               <a:t>Static, EIP-7928 style</a:t>
             </a:r>
@@ -8327,9 +7112,9 @@
                 <a:solidFill>
                   <a:srgbClr val="14181F"/>
                 </a:solidFill>
-                <a:latin typeface="Calibri" pitchFamily="34" charset="0"/>
-                <a:ea typeface="Calibri" pitchFamily="34" charset="-122"/>
-                <a:cs typeface="Calibri" pitchFamily="34" charset="-120"/>
+                <a:latin typeface="Arial" pitchFamily="34" charset="0"/>
+                <a:ea typeface="Arial" pitchFamily="34" charset="-122"/>
+                <a:cs typeface="Arial" pitchFamily="34" charset="-120"/>
               </a:rPr>
               <a:t>Derive every transaction's access set as a block builder would, then run conflict-free levels in parallel.</a:t>
             </a:r>
@@ -8369,9 +7154,9 @@
                 <a:solidFill>
                   <a:srgbClr val="14181F"/>
                 </a:solidFill>
-                <a:latin typeface="Calibri" pitchFamily="34" charset="0"/>
-                <a:ea typeface="Calibri" pitchFamily="34" charset="-122"/>
-                <a:cs typeface="Calibri" pitchFamily="34" charset="-120"/>
+                <a:latin typeface="Arial" pitchFamily="34" charset="0"/>
+                <a:ea typeface="Arial" pitchFamily="34" charset="-122"/>
+                <a:cs typeface="Arial" pitchFamily="34" charset="-120"/>
               </a:rPr>
               <a:t>+ No speculation, no aborts; fastest when conflicts are rare.</a:t>
             </a:r>
@@ -8411,9 +7196,9 @@
                 <a:solidFill>
                   <a:srgbClr val="5A6272"/>
                 </a:solidFill>
-                <a:latin typeface="Calibri" pitchFamily="34" charset="0"/>
-                <a:ea typeface="Calibri" pitchFamily="34" charset="-122"/>
-                <a:cs typeface="Calibri" pitchFamily="34" charset="-120"/>
+                <a:latin typeface="Arial" pitchFamily="34" charset="0"/>
+                <a:ea typeface="Arial" pitchFamily="34" charset="-122"/>
+                <a:cs typeface="Arial" pitchFamily="34" charset="-120"/>
               </a:rPr>
               <a:t>− One barrier per level of the chain; needs the access list first.</a:t>
             </a:r>
@@ -8482,9 +7267,9 @@
                 <a:solidFill>
                   <a:srgbClr val="EB6834"/>
                 </a:solidFill>
-                <a:latin typeface="Calibri" pitchFamily="34" charset="0"/>
-                <a:ea typeface="Calibri" pitchFamily="34" charset="-122"/>
-                <a:cs typeface="Calibri" pitchFamily="34" charset="-120"/>
+                <a:latin typeface="Arial" pitchFamily="34" charset="0"/>
+                <a:ea typeface="Arial" pitchFamily="34" charset="-122"/>
+                <a:cs typeface="Arial" pitchFamily="34" charset="-120"/>
               </a:rPr>
               <a:t>DECIDING WHAT CONFLICTS</a:t>
             </a:r>
@@ -8517,17 +7302,17 @@
               <a:buNone/>
             </a:pPr>
             <a:r>
-              <a:rPr lang="en-US" sz="3200" b="1" dirty="0">
+              <a:rPr lang="en-US" sz="2800" b="1" dirty="0">
                 <a:solidFill>
                   <a:srgbClr val="14181F"/>
                 </a:solidFill>
-                <a:latin typeface="Calibri" pitchFamily="34" charset="0"/>
-                <a:ea typeface="Calibri" pitchFamily="34" charset="-122"/>
-                <a:cs typeface="Calibri" pitchFamily="34" charset="-120"/>
+                <a:latin typeface="Arial" pitchFamily="34" charset="0"/>
+                <a:ea typeface="Arial" pitchFamily="34" charset="-122"/>
+                <a:cs typeface="Arial" pitchFamily="34" charset="-120"/>
               </a:rPr>
               <a:t>A conflict is a changed value — not a touched account</a:t>
             </a:r>
-            <a:endParaRPr lang="en-US" sz="3200" dirty="0"/>
+            <a:endParaRPr lang="en-US" sz="2800" dirty="0"/>
           </a:p>
         </p:txBody>
       </p:sp>
@@ -8587,9 +7372,9 @@
                 <a:solidFill>
                   <a:srgbClr val="FFFFFF"/>
                 </a:solidFill>
-                <a:latin typeface="Calibri" pitchFamily="34" charset="0"/>
-                <a:ea typeface="Calibri" pitchFamily="34" charset="-122"/>
-                <a:cs typeface="Calibri" pitchFamily="34" charset="-120"/>
+                <a:latin typeface="Arial" pitchFamily="34" charset="0"/>
+                <a:ea typeface="Arial" pitchFamily="34" charset="-122"/>
+                <a:cs typeface="Arial" pitchFamily="34" charset="-120"/>
               </a:rPr>
               <a:t>1</a:t>
             </a:r>
@@ -8626,9 +7411,9 @@
                 <a:solidFill>
                   <a:srgbClr val="14181F"/>
                 </a:solidFill>
-                <a:latin typeface="Calibri" pitchFamily="34" charset="0"/>
-                <a:ea typeface="Calibri" pitchFamily="34" charset="-122"/>
-                <a:cs typeface="Calibri" pitchFamily="34" charset="-120"/>
+                <a:latin typeface="Arial" pitchFamily="34" charset="0"/>
+                <a:ea typeface="Arial" pitchFamily="34" charset="-122"/>
+                <a:cs typeface="Arial" pitchFamily="34" charset="-120"/>
               </a:rPr>
               <a:t>Read set: every location the EVM loaded</a:t>
             </a:r>
@@ -8668,9 +7453,9 @@
                 <a:solidFill>
                   <a:srgbClr val="5A6272"/>
                 </a:solidFill>
-                <a:latin typeface="Calibri" pitchFamily="34" charset="0"/>
-                <a:ea typeface="Calibri" pitchFamily="34" charset="-122"/>
-                <a:cs typeface="Calibri" pitchFamily="34" charset="-120"/>
+                <a:latin typeface="Arial" pitchFamily="34" charset="0"/>
+                <a:ea typeface="Arial" pitchFamily="34" charset="-122"/>
+                <a:cs typeface="Arial" pitchFamily="34" charset="-120"/>
               </a:rPr>
               <a:t>Balances, nonces, code hashes, storage slots — captured at the database boundary, each with the version it resolved to. Validation compares versions, not values.</a:t>
             </a:r>
@@ -8734,9 +7519,9 @@
                 <a:solidFill>
                   <a:srgbClr val="FFFFFF"/>
                 </a:solidFill>
-                <a:latin typeface="Calibri" pitchFamily="34" charset="0"/>
-                <a:ea typeface="Calibri" pitchFamily="34" charset="-122"/>
-                <a:cs typeface="Calibri" pitchFamily="34" charset="-120"/>
+                <a:latin typeface="Arial" pitchFamily="34" charset="0"/>
+                <a:ea typeface="Arial" pitchFamily="34" charset="-122"/>
+                <a:cs typeface="Arial" pitchFamily="34" charset="-120"/>
               </a:rPr>
               <a:t>2</a:t>
             </a:r>
@@ -8773,9 +7558,9 @@
                 <a:solidFill>
                   <a:srgbClr val="14181F"/>
                 </a:solidFill>
-                <a:latin typeface="Calibri" pitchFamily="34" charset="0"/>
-                <a:ea typeface="Calibri" pitchFamily="34" charset="-122"/>
-                <a:cs typeface="Calibri" pitchFamily="34" charset="-120"/>
+                <a:latin typeface="Arial" pitchFamily="34" charset="0"/>
+                <a:ea typeface="Arial" pitchFamily="34" charset="-122"/>
+                <a:cs typeface="Arial" pitchFamily="34" charset="-120"/>
               </a:rPr>
               <a:t>Write set: only what actually changed</a:t>
             </a:r>
@@ -8815,9 +7600,9 @@
                 <a:solidFill>
                   <a:srgbClr val="5A6272"/>
                 </a:solidFill>
-                <a:latin typeface="Calibri" pitchFamily="34" charset="0"/>
-                <a:ea typeface="Calibri" pitchFamily="34" charset="-122"/>
-                <a:cs typeface="Calibri" pitchFamily="34" charset="-120"/>
+                <a:latin typeface="Arial" pitchFamily="34" charset="0"/>
+                <a:ea typeface="Arial" pitchFamily="34" charset="-122"/>
+                <a:cs typeface="Arial" pitchFamily="34" charset="-120"/>
               </a:rPr>
               <a:t>Calling a contract touches its account without changing it. Counting touched as written made every call to one contract conflict with every other — a bug our benchmarks exposed.</a:t>
             </a:r>
@@ -8881,9 +7666,9 @@
                 <a:solidFill>
                   <a:srgbClr val="FFFFFF"/>
                 </a:solidFill>
-                <a:latin typeface="Calibri" pitchFamily="34" charset="0"/>
-                <a:ea typeface="Calibri" pitchFamily="34" charset="-122"/>
-                <a:cs typeface="Calibri" pitchFamily="34" charset="-120"/>
+                <a:latin typeface="Arial" pitchFamily="34" charset="0"/>
+                <a:ea typeface="Arial" pitchFamily="34" charset="-122"/>
+                <a:cs typeface="Arial" pitchFamily="34" charset="-120"/>
               </a:rPr>
               <a:t>3</a:t>
             </a:r>
@@ -8920,9 +7705,9 @@
                 <a:solidFill>
                   <a:srgbClr val="14181F"/>
                 </a:solidFill>
-                <a:latin typeface="Calibri" pitchFamily="34" charset="0"/>
-                <a:ea typeface="Calibri" pitchFamily="34" charset="-122"/>
-                <a:cs typeface="Calibri" pitchFamily="34" charset="-120"/>
+                <a:latin typeface="Arial" pitchFamily="34" charset="0"/>
+                <a:ea typeface="Arial" pitchFamily="34" charset="-122"/>
+                <a:cs typeface="Arial" pitchFamily="34" charset="-120"/>
               </a:rPr>
               <a:t>The fee recipient is an accumulator</a:t>
             </a:r>
@@ -8962,9 +7747,9 @@
                 <a:solidFill>
                   <a:srgbClr val="5A6272"/>
                 </a:solidFill>
-                <a:latin typeface="Calibri" pitchFamily="34" charset="0"/>
-                <a:ea typeface="Calibri" pitchFamily="34" charset="-122"/>
-                <a:cs typeface="Calibri" pitchFamily="34" charset="-120"/>
+                <a:latin typeface="Arial" pitchFamily="34" charset="0"/>
+                <a:ea typeface="Arial" pitchFamily="34" charset="-122"/>
+                <a:cs typeface="Arial" pitchFamily="34" charset="-120"/>
               </a:rPr>
               <a:t>Every transaction pays the block beneficiary. Fees add up in any order, so they are kept out of conflict detection and summed at commit.</a:t>
             </a:r>
@@ -9031,9 +7816,9 @@
                 <a:solidFill>
                   <a:srgbClr val="14181F"/>
                 </a:solidFill>
-                <a:latin typeface="Calibri" pitchFamily="34" charset="0"/>
-                <a:ea typeface="Calibri" pitchFamily="34" charset="-122"/>
-                <a:cs typeface="Calibri" pitchFamily="34" charset="-120"/>
+                <a:latin typeface="Arial" pitchFamily="34" charset="0"/>
+                <a:ea typeface="Arial" pitchFamily="34" charset="-122"/>
+                <a:cs typeface="Arial" pitchFamily="34" charset="-120"/>
               </a:rPr>
               <a:t>Granularity is a choice</a:t>
             </a:r>
@@ -9073,9 +7858,9 @@
                 <a:solidFill>
                   <a:srgbClr val="14181F"/>
                 </a:solidFill>
-                <a:latin typeface="Calibri" pitchFamily="34" charset="0"/>
-                <a:ea typeface="Calibri" pitchFamily="34" charset="-122"/>
-                <a:cs typeface="Calibri" pitchFamily="34" charset="-120"/>
+                <a:latin typeface="Arial" pitchFamily="34" charset="0"/>
+                <a:ea typeface="Arial" pitchFamily="34" charset="-122"/>
+                <a:cs typeface="Arial" pitchFamily="34" charset="-120"/>
               </a:rPr>
               <a:t>Per storage slot: two ERC-20 transfers between different holders are independent.</a:t>
             </a:r>
@@ -9102,9 +7887,9 @@
                 <a:solidFill>
                   <a:srgbClr val="14181F"/>
                 </a:solidFill>
-                <a:latin typeface="Calibri" pitchFamily="34" charset="0"/>
-                <a:ea typeface="Calibri" pitchFamily="34" charset="-122"/>
-                <a:cs typeface="Calibri" pitchFamily="34" charset="-120"/>
+                <a:latin typeface="Arial" pitchFamily="34" charset="0"/>
+                <a:ea typeface="Arial" pitchFamily="34" charset="-122"/>
+                <a:cs typeface="Arial" pitchFamily="34" charset="-120"/>
               </a:rPr>
               <a:t>Per account: every ERC-20 balance lives in the token contract's account — so every transfer conflicts with every other.</a:t>
             </a:r>
@@ -9131,9 +7916,9 @@
                 <a:solidFill>
                   <a:srgbClr val="14181F"/>
                 </a:solidFill>
-                <a:latin typeface="Calibri" pitchFamily="34" charset="0"/>
-                <a:ea typeface="Calibri" pitchFamily="34" charset="-122"/>
-                <a:cs typeface="Calibri" pitchFamily="34" charset="-120"/>
+                <a:latin typeface="Arial" pitchFamily="34" charset="0"/>
+                <a:ea typeface="Arial" pitchFamily="34" charset="-122"/>
+                <a:cs typeface="Arial" pitchFamily="34" charset="-120"/>
               </a:rPr>
               <a:t>We implemented both and measured the difference (slide 11).</a:t>
             </a:r>
@@ -9202,9 +7987,9 @@
                 <a:solidFill>
                   <a:srgbClr val="EB6834"/>
                 </a:solidFill>
-                <a:latin typeface="Calibri" pitchFamily="34" charset="0"/>
-                <a:ea typeface="Calibri" pitchFamily="34" charset="-122"/>
-                <a:cs typeface="Calibri" pitchFamily="34" charset="-120"/>
+                <a:latin typeface="Arial" pitchFamily="34" charset="0"/>
+                <a:ea typeface="Arial" pitchFamily="34" charset="-122"/>
+                <a:cs typeface="Arial" pitchFamily="34" charset="-120"/>
               </a:rPr>
               <a:t>CORRECTNESS FIRST</a:t>
             </a:r>
@@ -9237,17 +8022,17 @@
               <a:buNone/>
             </a:pPr>
             <a:r>
-              <a:rPr lang="en-US" sz="3200" b="1" dirty="0">
+              <a:rPr lang="en-US" sz="2800" b="1" dirty="0">
                 <a:solidFill>
                   <a:srgbClr val="FFFFFF"/>
                 </a:solidFill>
-                <a:latin typeface="Calibri" pitchFamily="34" charset="0"/>
-                <a:ea typeface="Calibri" pitchFamily="34" charset="-122"/>
-                <a:cs typeface="Calibri" pitchFamily="34" charset="-120"/>
+                <a:latin typeface="Arial" pitchFamily="34" charset="0"/>
+                <a:ea typeface="Arial" pitchFamily="34" charset="-122"/>
+                <a:cs typeface="Arial" pitchFamily="34" charset="-120"/>
               </a:rPr>
               <a:t>Every parallel result is bit-identical to sequential — and checked</a:t>
             </a:r>
-            <a:endParaRPr lang="en-US" sz="3200" dirty="0"/>
+            <a:endParaRPr lang="en-US" sz="2800" dirty="0"/>
           </a:p>
         </p:txBody>
       </p:sp>
@@ -9280,9 +8065,9 @@
                 <a:solidFill>
                   <a:srgbClr val="EB6834"/>
                 </a:solidFill>
-                <a:latin typeface="Calibri" pitchFamily="34" charset="0"/>
-                <a:ea typeface="Calibri" pitchFamily="34" charset="-122"/>
-                <a:cs typeface="Calibri" pitchFamily="34" charset="-120"/>
+                <a:latin typeface="Arial" pitchFamily="34" charset="0"/>
+                <a:ea typeface="Arial" pitchFamily="34" charset="-122"/>
+                <a:cs typeface="Arial" pitchFamily="34" charset="-120"/>
               </a:rPr>
               <a:t>1,000</a:t>
             </a:r>
@@ -9319,9 +8104,9 @@
                 <a:solidFill>
                   <a:srgbClr val="AEB6C8"/>
                 </a:solidFill>
-                <a:latin typeface="Calibri" pitchFamily="34" charset="0"/>
-                <a:ea typeface="Calibri" pitchFamily="34" charset="-122"/>
-                <a:cs typeface="Calibri" pitchFamily="34" charset="-120"/>
+                <a:latin typeface="Arial" pitchFamily="34" charset="0"/>
+                <a:ea typeface="Arial" pitchFamily="34" charset="-122"/>
+                <a:cs typeface="Arial" pitchFamily="34" charset="-120"/>
               </a:rPr>
               <a:t>seeds per workload, every scheduler, 2–12 threads — slot-for-slot against an independent sequential engine</a:t>
             </a:r>
@@ -9358,9 +8143,9 @@
                 <a:solidFill>
                   <a:srgbClr val="1BAF7A"/>
                 </a:solidFill>
-                <a:latin typeface="Calibri" pitchFamily="34" charset="0"/>
-                <a:ea typeface="Calibri" pitchFamily="34" charset="-122"/>
-                <a:cs typeface="Calibri" pitchFamily="34" charset="-120"/>
+                <a:latin typeface="Arial" pitchFamily="34" charset="0"/>
+                <a:ea typeface="Arial" pitchFamily="34" charset="-122"/>
+                <a:cs typeface="Arial" pitchFamily="34" charset="-120"/>
               </a:rPr>
               <a:t>9 / 9</a:t>
             </a:r>
@@ -9397,9 +8182,9 @@
                 <a:solidFill>
                   <a:srgbClr val="AEB6C8"/>
                 </a:solidFill>
-                <a:latin typeface="Calibri" pitchFamily="34" charset="0"/>
-                <a:ea typeface="Calibri" pitchFamily="34" charset="-122"/>
-                <a:cs typeface="Calibri" pitchFamily="34" charset="-120"/>
+                <a:latin typeface="Arial" pitchFamily="34" charset="0"/>
+                <a:ea typeface="Arial" pitchFamily="34" charset="-122"/>
+                <a:cs typeface="Arial" pitchFamily="34" charset="-120"/>
               </a:rPr>
               <a:t>workloads where our sequential engine matches an Anvil node: balances, nonces, code, storage, reverts</a:t>
             </a:r>
@@ -9436,9 +8221,9 @@
                 <a:solidFill>
                   <a:srgbClr val="FFFFFF"/>
                 </a:solidFill>
-                <a:latin typeface="Calibri" pitchFamily="34" charset="0"/>
-                <a:ea typeface="Calibri" pitchFamily="34" charset="-122"/>
-                <a:cs typeface="Calibri" pitchFamily="34" charset="-120"/>
+                <a:latin typeface="Arial" pitchFamily="34" charset="0"/>
+                <a:ea typeface="Arial" pitchFamily="34" charset="-122"/>
+                <a:cs typeface="Arial" pitchFamily="34" charset="-120"/>
               </a:rPr>
               <a:t>15</a:t>
             </a:r>
@@ -9475,9 +8260,9 @@
                 <a:solidFill>
                   <a:srgbClr val="AEB6C8"/>
                 </a:solidFill>
-                <a:latin typeface="Calibri" pitchFamily="34" charset="0"/>
-                <a:ea typeface="Calibri" pitchFamily="34" charset="-122"/>
-                <a:cs typeface="Calibri" pitchFamily="34" charset="-120"/>
+                <a:latin typeface="Arial" pitchFamily="34" charset="0"/>
+                <a:ea typeface="Arial" pitchFamily="34" charset="-122"/>
+                <a:cs typeface="Arial" pitchFamily="34" charset="-120"/>
               </a:rPr>
               <a:t>bugs injected on purpose to test the tests — all caught, after two gaps in the tests were found and closed</a:t>
             </a:r>
@@ -9544,9 +8329,9 @@
                 <a:solidFill>
                   <a:srgbClr val="FFFFFF"/>
                 </a:solidFill>
-                <a:latin typeface="Calibri" pitchFamily="34" charset="0"/>
-                <a:ea typeface="Calibri" pitchFamily="34" charset="-122"/>
-                <a:cs typeface="Calibri" pitchFamily="34" charset="-120"/>
+                <a:latin typeface="Arial" pitchFamily="34" charset="0"/>
+                <a:ea typeface="Arial" pitchFamily="34" charset="-122"/>
+                <a:cs typeface="Arial" pitchFamily="34" charset="-120"/>
               </a:rPr>
               <a:t>Real bugs the tests found</a:t>
             </a:r>
@@ -9586,9 +8371,9 @@
                 <a:solidFill>
                   <a:srgbClr val="AEB6C8"/>
                 </a:solidFill>
-                <a:latin typeface="Calibri" pitchFamily="34" charset="0"/>
-                <a:ea typeface="Calibri" pitchFamily="34" charset="-122"/>
-                <a:cs typeface="Calibri" pitchFamily="34" charset="-120"/>
+                <a:latin typeface="Arial" pitchFamily="34" charset="0"/>
+                <a:ea typeface="Arial" pitchFamily="34" charset="-122"/>
+                <a:cs typeface="Arial" pitchFamily="34" charset="-120"/>
               </a:rPr>
               <a:t>Generated accounts landed on precompile addresses — 15% of a block silently called ecrecover instead of transferring.</a:t>
             </a:r>
@@ -9606,9 +8391,9 @@
                 <a:solidFill>
                   <a:srgbClr val="AEB6C8"/>
                 </a:solidFill>
-                <a:latin typeface="Calibri" pitchFamily="34" charset="0"/>
-                <a:ea typeface="Calibri" pitchFamily="34" charset="-122"/>
-                <a:cs typeface="Calibri" pitchFamily="34" charset="-120"/>
+                <a:latin typeface="Arial" pitchFamily="34" charset="0"/>
+                <a:ea typeface="Arial" pitchFamily="34" charset="-122"/>
+                <a:cs typeface="Arial" pitchFamily="34" charset="-120"/>
               </a:rPr>
               <a:t>Touched-but-unchanged accounts counted as writes — every contract workload serialised through its own contract.</a:t>
             </a:r>
@@ -9626,9 +8411,9 @@
                 <a:solidFill>
                   <a:srgbClr val="AEB6C8"/>
                 </a:solidFill>
-                <a:latin typeface="Calibri" pitchFamily="34" charset="0"/>
-                <a:ea typeface="Calibri" pitchFamily="34" charset="-122"/>
-                <a:cs typeface="Calibri" pitchFamily="34" charset="-120"/>
+                <a:latin typeface="Arial" pitchFamily="34" charset="0"/>
+                <a:ea typeface="Arial" pitchFamily="34" charset="-122"/>
+                <a:cs typeface="Arial" pitchFamily="34" charset="-120"/>
               </a:rPr>
               <a:t>A read race under account granularity let a stale nonce pass validation — appeared once in a full run, reproduced by a stress test in 0.5 s.</a:t>
             </a:r>
@@ -9697,9 +8482,9 @@
                 <a:solidFill>
                   <a:srgbClr val="EB6834"/>
                 </a:solidFill>
-                <a:latin typeface="Calibri" pitchFamily="34" charset="0"/>
-                <a:ea typeface="Calibri" pitchFamily="34" charset="-122"/>
-                <a:cs typeface="Calibri" pitchFamily="34" charset="-120"/>
+                <a:latin typeface="Arial" pitchFamily="34" charset="0"/>
+                <a:ea typeface="Arial" pitchFamily="34" charset="-122"/>
+                <a:cs typeface="Arial" pitchFamily="34" charset="-120"/>
               </a:rPr>
               <a:t>RESULT 1</a:t>
             </a:r>
@@ -9732,17 +8517,17 @@
               <a:buNone/>
             </a:pPr>
             <a:r>
-              <a:rPr lang="en-US" sz="3200" b="1" dirty="0">
+              <a:rPr lang="en-US" sz="2800" b="1" dirty="0">
                 <a:solidFill>
                   <a:srgbClr val="14181F"/>
                 </a:solidFill>
-                <a:latin typeface="Calibri" pitchFamily="34" charset="0"/>
-                <a:ea typeface="Calibri" pitchFamily="34" charset="-122"/>
-                <a:cs typeface="Calibri" pitchFamily="34" charset="-120"/>
+                <a:latin typeface="Arial" pitchFamily="34" charset="0"/>
+                <a:ea typeface="Arial" pitchFamily="34" charset="-122"/>
+                <a:cs typeface="Arial" pitchFamily="34" charset="-120"/>
               </a:rPr>
               <a:t>Three regimes: scales, scales a little, gets slower</a:t>
             </a:r>
-            <a:endParaRPr lang="en-US" sz="3200" dirty="0"/>
+            <a:endParaRPr lang="en-US" sz="2800" dirty="0"/>
           </a:p>
         </p:txBody>
       </p:sp>
@@ -9802,9 +8587,9 @@
                 <a:solidFill>
                   <a:srgbClr val="14181F"/>
                 </a:solidFill>
-                <a:latin typeface="Calibri" pitchFamily="34" charset="0"/>
-                <a:ea typeface="Calibri" pitchFamily="34" charset="-122"/>
-                <a:cs typeface="Calibri" pitchFamily="34" charset="-120"/>
+                <a:latin typeface="Arial" pitchFamily="34" charset="0"/>
+                <a:ea typeface="Arial" pitchFamily="34" charset="-122"/>
+                <a:cs typeface="Arial" pitchFamily="34" charset="-120"/>
               </a:rPr>
               <a:t>Independent and heavy</a:t>
             </a:r>
@@ -9844,9 +8629,9 @@
                 <a:solidFill>
                   <a:srgbClr val="14181F"/>
                 </a:solidFill>
-                <a:latin typeface="Calibri" pitchFamily="34" charset="0"/>
-                <a:ea typeface="Calibri" pitchFamily="34" charset="-122"/>
-                <a:cs typeface="Calibri" pitchFamily="34" charset="-120"/>
+                <a:latin typeface="Arial" pitchFamily="34" charset="0"/>
+                <a:ea typeface="Arial" pitchFamily="34" charset="-122"/>
+                <a:cs typeface="Arial" pitchFamily="34" charset="-120"/>
               </a:rPr>
               <a:t>compute calls reach 5.2× at 6 threads and keep climbing onto efficiency cores.</a:t>
             </a:r>
@@ -9886,9 +8671,9 @@
                 <a:solidFill>
                   <a:srgbClr val="14181F"/>
                 </a:solidFill>
-                <a:latin typeface="Calibri" pitchFamily="34" charset="0"/>
-                <a:ea typeface="Calibri" pitchFamily="34" charset="-122"/>
-                <a:cs typeface="Calibri" pitchFamily="34" charset="-120"/>
+                <a:latin typeface="Arial" pitchFamily="34" charset="0"/>
+                <a:ea typeface="Arial" pitchFamily="34" charset="-122"/>
+                <a:cs typeface="Arial" pitchFamily="34" charset="-120"/>
               </a:rPr>
               <a:t>Independent and light</a:t>
             </a:r>
@@ -9928,9 +8713,9 @@
                 <a:solidFill>
                   <a:srgbClr val="14181F"/>
                 </a:solidFill>
-                <a:latin typeface="Calibri" pitchFamily="34" charset="0"/>
-                <a:ea typeface="Calibri" pitchFamily="34" charset="-122"/>
-                <a:cs typeface="Calibri" pitchFamily="34" charset="-120"/>
+                <a:latin typeface="Arial" pitchFamily="34" charset="0"/>
+                <a:ea typeface="Arial" pitchFamily="34" charset="-122"/>
+                <a:cs typeface="Arial" pitchFamily="34" charset="-120"/>
               </a:rPr>
               <a:t>ETH and ERC-20 transfers peak at 1.4–3.0× around 4–6 threads, then lose speed on efficiency cores.</a:t>
             </a:r>
@@ -9970,9 +8755,9 @@
                 <a:solidFill>
                   <a:srgbClr val="14181F"/>
                 </a:solidFill>
-                <a:latin typeface="Calibri" pitchFamily="34" charset="0"/>
-                <a:ea typeface="Calibri" pitchFamily="34" charset="-122"/>
-                <a:cs typeface="Calibri" pitchFamily="34" charset="-120"/>
+                <a:latin typeface="Arial" pitchFamily="34" charset="0"/>
+                <a:ea typeface="Arial" pitchFamily="34" charset="-122"/>
+                <a:cs typeface="Arial" pitchFamily="34" charset="-120"/>
               </a:rPr>
               <a:t>Dependent</a:t>
             </a:r>
@@ -10012,9 +8797,9 @@
                 <a:solidFill>
                   <a:srgbClr val="14181F"/>
                 </a:solidFill>
-                <a:latin typeface="Calibri" pitchFamily="34" charset="0"/>
-                <a:ea typeface="Calibri" pitchFamily="34" charset="-122"/>
-                <a:cs typeface="Calibri" pitchFamily="34" charset="-120"/>
+                <a:latin typeface="Arial" pitchFamily="34" charset="0"/>
+                <a:ea typeface="Arial" pitchFamily="34" charset="-122"/>
+                <a:cs typeface="Arial" pitchFamily="34" charset="-120"/>
               </a:rPr>
               <a:t>NFT mint and one AMM pool: every scheduler is slower than sequential.</a:t>
             </a:r>
@@ -10051,9 +8836,9 @@
                 <a:solidFill>
                   <a:srgbClr val="5A6272"/>
                 </a:solidFill>
-                <a:latin typeface="Calibri" pitchFamily="34" charset="0"/>
-                <a:ea typeface="Calibri" pitchFamily="34" charset="-122"/>
-                <a:cs typeface="Calibri" pitchFamily="34" charset="-120"/>
+                <a:latin typeface="Arial" pitchFamily="34" charset="0"/>
+                <a:ea typeface="Arial" pitchFamily="34" charset="-122"/>
+                <a:cs typeface="Arial" pitchFamily="34" charset="-120"/>
               </a:rPr>
               <a:t>Shaded: threads beyond the 6 performance cores. Median of 5 runs; every run verified.</a:t>
             </a:r>
@@ -10122,9 +8907,9 @@
                 <a:solidFill>
                   <a:srgbClr val="EB6834"/>
                 </a:solidFill>
-                <a:latin typeface="Calibri" pitchFamily="34" charset="0"/>
-                <a:ea typeface="Calibri" pitchFamily="34" charset="-122"/>
-                <a:cs typeface="Calibri" pitchFamily="34" charset="-120"/>
+                <a:latin typeface="Arial" pitchFamily="34" charset="0"/>
+                <a:ea typeface="Arial" pitchFamily="34" charset="-122"/>
+                <a:cs typeface="Arial" pitchFamily="34" charset="-120"/>
               </a:rPr>
               <a:t>RESULT 2</a:t>
             </a:r>
@@ -10157,17 +8942,17 @@
               <a:buNone/>
             </a:pPr>
             <a:r>
-              <a:rPr lang="en-US" sz="3200" b="1" dirty="0">
+              <a:rPr lang="en-US" sz="2800" b="1" dirty="0">
                 <a:solidFill>
                   <a:srgbClr val="14181F"/>
                 </a:solidFill>
-                <a:latin typeface="Calibri" pitchFamily="34" charset="0"/>
-                <a:ea typeface="Calibri" pitchFamily="34" charset="-122"/>
-                <a:cs typeface="Calibri" pitchFamily="34" charset="-120"/>
+                <a:latin typeface="Arial" pitchFamily="34" charset="0"/>
+                <a:ea typeface="Arial" pitchFamily="34" charset="-122"/>
+                <a:cs typeface="Arial" pitchFamily="34" charset="-120"/>
               </a:rPr>
               <a:t>Chain length kills speedup — not how many transactions conflict</a:t>
             </a:r>
-            <a:endParaRPr lang="en-US" sz="3200" dirty="0"/>
+            <a:endParaRPr lang="en-US" sz="2800" dirty="0"/>
           </a:p>
         </p:txBody>
       </p:sp>
@@ -10227,9 +9012,9 @@
                 <a:solidFill>
                   <a:srgbClr val="5A6272"/>
                 </a:solidFill>
-                <a:latin typeface="Calibri" pitchFamily="34" charset="0"/>
-                <a:ea typeface="Calibri" pitchFamily="34" charset="-122"/>
-                <a:cs typeface="Calibri" pitchFamily="34" charset="-120"/>
+                <a:latin typeface="Arial" pitchFamily="34" charset="0"/>
+                <a:ea typeface="Arial" pitchFamily="34" charset="-122"/>
+                <a:cs typeface="Arial" pitchFamily="34" charset="-120"/>
               </a:rPr>
               <a:t>Block-STM, 6 threads</a:t>
             </a:r>
@@ -10279,16 +9064,16 @@
                           <a:solidFill>
                             <a:srgbClr val="5A6272"/>
                           </a:solidFill>
-                          <a:latin typeface="Calibri" pitchFamily="34" charset="0"/>
-                          <a:ea typeface="Calibri" pitchFamily="34" charset="-122"/>
-                          <a:cs typeface="Calibri" pitchFamily="34" charset="-120"/>
+                          <a:latin typeface="Arial" pitchFamily="34" charset="0"/>
+                          <a:ea typeface="Arial" pitchFamily="34" charset="-122"/>
+                          <a:cs typeface="Arial" pitchFamily="34" charset="-120"/>
                         </a:rPr>
                         <a:t>Workload</a:t>
                       </a:r>
                       <a:endParaRPr lang="en-US" sz="1300" dirty="0">
-                        <a:latin typeface="Calibri" charset="0"/>
-                        <a:ea typeface="Calibri" charset="0"/>
-                        <a:cs typeface="Calibri" charset="0"/>
+                        <a:latin typeface="Arial" charset="0"/>
+                        <a:ea typeface="Arial" charset="0"/>
+                        <a:cs typeface="Arial" charset="0"/>
                       </a:endParaRPr>
                     </a:p>
                   </a:txBody>
@@ -10326,16 +9111,16 @@
                           <a:solidFill>
                             <a:srgbClr val="5A6272"/>
                           </a:solidFill>
-                          <a:latin typeface="Calibri" pitchFamily="34" charset="0"/>
-                          <a:ea typeface="Calibri" pitchFamily="34" charset="-122"/>
-                          <a:cs typeface="Calibri" pitchFamily="34" charset="-120"/>
+                          <a:latin typeface="Arial" pitchFamily="34" charset="0"/>
+                          <a:ea typeface="Arial" pitchFamily="34" charset="-122"/>
+                          <a:cs typeface="Arial" pitchFamily="34" charset="-120"/>
                         </a:rPr>
                         <a:t>Density</a:t>
                       </a:r>
                       <a:endParaRPr lang="en-US" sz="1300" dirty="0">
-                        <a:latin typeface="Calibri" charset="0"/>
-                        <a:ea typeface="Calibri" charset="0"/>
-                        <a:cs typeface="Calibri" charset="0"/>
+                        <a:latin typeface="Arial" charset="0"/>
+                        <a:ea typeface="Arial" charset="0"/>
+                        <a:cs typeface="Arial" charset="0"/>
                       </a:endParaRPr>
                     </a:p>
                   </a:txBody>
@@ -10373,16 +9158,16 @@
                           <a:solidFill>
                             <a:srgbClr val="5A6272"/>
                           </a:solidFill>
-                          <a:latin typeface="Calibri" pitchFamily="34" charset="0"/>
-                          <a:ea typeface="Calibri" pitchFamily="34" charset="-122"/>
-                          <a:cs typeface="Calibri" pitchFamily="34" charset="-120"/>
+                          <a:latin typeface="Arial" pitchFamily="34" charset="0"/>
+                          <a:ea typeface="Arial" pitchFamily="34" charset="-122"/>
+                          <a:cs typeface="Arial" pitchFamily="34" charset="-120"/>
                         </a:rPr>
                         <a:t>Chain</a:t>
                       </a:r>
                       <a:endParaRPr lang="en-US" sz="1300" dirty="0">
-                        <a:latin typeface="Calibri" charset="0"/>
-                        <a:ea typeface="Calibri" charset="0"/>
-                        <a:cs typeface="Calibri" charset="0"/>
+                        <a:latin typeface="Arial" charset="0"/>
+                        <a:ea typeface="Arial" charset="0"/>
+                        <a:cs typeface="Arial" charset="0"/>
                       </a:endParaRPr>
                     </a:p>
                   </a:txBody>
@@ -10420,16 +9205,16 @@
                           <a:solidFill>
                             <a:srgbClr val="5A6272"/>
                           </a:solidFill>
-                          <a:latin typeface="Calibri" pitchFamily="34" charset="0"/>
-                          <a:ea typeface="Calibri" pitchFamily="34" charset="-122"/>
-                          <a:cs typeface="Calibri" pitchFamily="34" charset="-120"/>
+                          <a:latin typeface="Arial" pitchFamily="34" charset="0"/>
+                          <a:ea typeface="Arial" pitchFamily="34" charset="-122"/>
+                          <a:cs typeface="Arial" pitchFamily="34" charset="-120"/>
                         </a:rPr>
                         <a:t>Speedup</a:t>
                       </a:r>
                       <a:endParaRPr lang="en-US" sz="1300" dirty="0">
-                        <a:latin typeface="Calibri" charset="0"/>
-                        <a:ea typeface="Calibri" charset="0"/>
-                        <a:cs typeface="Calibri" charset="0"/>
+                        <a:latin typeface="Arial" charset="0"/>
+                        <a:ea typeface="Arial" charset="0"/>
+                        <a:cs typeface="Arial" charset="0"/>
                       </a:endParaRPr>
                     </a:p>
                   </a:txBody>
@@ -10469,16 +9254,16 @@
                           <a:solidFill>
                             <a:srgbClr val="14181F"/>
                           </a:solidFill>
-                          <a:latin typeface="Calibri" pitchFamily="34" charset="0"/>
-                          <a:ea typeface="Calibri" pitchFamily="34" charset="-122"/>
-                          <a:cs typeface="Calibri" pitchFamily="34" charset="-120"/>
+                          <a:latin typeface="Arial" pitchFamily="34" charset="0"/>
+                          <a:ea typeface="Arial" pitchFamily="34" charset="-122"/>
+                          <a:cs typeface="Arial" pitchFamily="34" charset="-120"/>
                         </a:rPr>
                         <a:t>transfers, r = 1</a:t>
                       </a:r>
                       <a:endParaRPr lang="en-US" sz="1300" dirty="0">
-                        <a:latin typeface="Calibri" charset="0"/>
-                        <a:ea typeface="Calibri" charset="0"/>
-                        <a:cs typeface="Calibri" charset="0"/>
+                        <a:latin typeface="Arial" charset="0"/>
+                        <a:ea typeface="Arial" charset="0"/>
+                        <a:cs typeface="Arial" charset="0"/>
                       </a:endParaRPr>
                     </a:p>
                   </a:txBody>
@@ -10516,16 +9301,16 @@
                           <a:solidFill>
                             <a:srgbClr val="14181F"/>
                           </a:solidFill>
-                          <a:latin typeface="Calibri" pitchFamily="34" charset="0"/>
-                          <a:ea typeface="Calibri" pitchFamily="34" charset="-122"/>
-                          <a:cs typeface="Calibri" pitchFamily="34" charset="-120"/>
+                          <a:latin typeface="Arial" pitchFamily="34" charset="0"/>
+                          <a:ea typeface="Arial" pitchFamily="34" charset="-122"/>
+                          <a:cs typeface="Arial" pitchFamily="34" charset="-120"/>
                         </a:rPr>
                         <a:t>0.75</a:t>
                       </a:r>
                       <a:endParaRPr lang="en-US" sz="1300" dirty="0">
-                        <a:latin typeface="Calibri" charset="0"/>
-                        <a:ea typeface="Calibri" charset="0"/>
-                        <a:cs typeface="Calibri" charset="0"/>
+                        <a:latin typeface="Arial" charset="0"/>
+                        <a:ea typeface="Arial" charset="0"/>
+                        <a:cs typeface="Arial" charset="0"/>
                       </a:endParaRPr>
                     </a:p>
                   </a:txBody>
@@ -10563,16 +9348,16 @@
                           <a:solidFill>
                             <a:srgbClr val="14181F"/>
                           </a:solidFill>
-                          <a:latin typeface="Calibri" pitchFamily="34" charset="0"/>
-                          <a:ea typeface="Calibri" pitchFamily="34" charset="-122"/>
-                          <a:cs typeface="Calibri" pitchFamily="34" charset="-120"/>
+                          <a:latin typeface="Arial" pitchFamily="34" charset="0"/>
+                          <a:ea typeface="Arial" pitchFamily="34" charset="-122"/>
+                          <a:cs typeface="Arial" pitchFamily="34" charset="-120"/>
                         </a:rPr>
                         <a:t>11</a:t>
                       </a:r>
                       <a:endParaRPr lang="en-US" sz="1300" dirty="0">
-                        <a:latin typeface="Calibri" charset="0"/>
-                        <a:ea typeface="Calibri" charset="0"/>
-                        <a:cs typeface="Calibri" charset="0"/>
+                        <a:latin typeface="Arial" charset="0"/>
+                        <a:ea typeface="Arial" charset="0"/>
+                        <a:cs typeface="Arial" charset="0"/>
                       </a:endParaRPr>
                     </a:p>
                   </a:txBody>
@@ -10610,16 +9395,16 @@
                           <a:solidFill>
                             <a:srgbClr val="14181F"/>
                           </a:solidFill>
-                          <a:latin typeface="Calibri" pitchFamily="34" charset="0"/>
-                          <a:ea typeface="Calibri" pitchFamily="34" charset="-122"/>
-                          <a:cs typeface="Calibri" pitchFamily="34" charset="-120"/>
+                          <a:latin typeface="Arial" pitchFamily="34" charset="0"/>
+                          <a:ea typeface="Arial" pitchFamily="34" charset="-122"/>
+                          <a:cs typeface="Arial" pitchFamily="34" charset="-120"/>
                         </a:rPr>
                         <a:t>1.29×</a:t>
                       </a:r>
                       <a:endParaRPr lang="en-US" sz="1300" dirty="0">
-                        <a:latin typeface="Calibri" charset="0"/>
-                        <a:ea typeface="Calibri" charset="0"/>
-                        <a:cs typeface="Calibri" charset="0"/>
+                        <a:latin typeface="Arial" charset="0"/>
+                        <a:ea typeface="Arial" charset="0"/>
+                        <a:cs typeface="Arial" charset="0"/>
                       </a:endParaRPr>
                     </a:p>
                   </a:txBody>
@@ -10659,16 +9444,16 @@
                           <a:solidFill>
                             <a:srgbClr val="14181F"/>
                           </a:solidFill>
-                          <a:latin typeface="Calibri" pitchFamily="34" charset="0"/>
-                          <a:ea typeface="Calibri" pitchFamily="34" charset="-122"/>
-                          <a:cs typeface="Calibri" pitchFamily="34" charset="-120"/>
+                          <a:latin typeface="Arial" pitchFamily="34" charset="0"/>
+                          <a:ea typeface="Arial" pitchFamily="34" charset="-122"/>
+                          <a:cs typeface="Arial" pitchFamily="34" charset="-120"/>
                         </a:rPr>
                         <a:t>transfers, Zipf 0.8</a:t>
                       </a:r>
                       <a:endParaRPr lang="en-US" sz="1300" dirty="0">
-                        <a:latin typeface="Calibri" charset="0"/>
-                        <a:ea typeface="Calibri" charset="0"/>
-                        <a:cs typeface="Calibri" charset="0"/>
+                        <a:latin typeface="Arial" charset="0"/>
+                        <a:ea typeface="Arial" charset="0"/>
+                        <a:cs typeface="Arial" charset="0"/>
                       </a:endParaRPr>
                     </a:p>
                   </a:txBody>
@@ -10706,16 +9491,16 @@
                           <a:solidFill>
                             <a:srgbClr val="14181F"/>
                           </a:solidFill>
-                          <a:latin typeface="Calibri" pitchFamily="34" charset="0"/>
-                          <a:ea typeface="Calibri" pitchFamily="34" charset="-122"/>
-                          <a:cs typeface="Calibri" pitchFamily="34" charset="-120"/>
+                          <a:latin typeface="Arial" pitchFamily="34" charset="0"/>
+                          <a:ea typeface="Arial" pitchFamily="34" charset="-122"/>
+                          <a:cs typeface="Arial" pitchFamily="34" charset="-120"/>
                         </a:rPr>
                         <a:t>0.81</a:t>
                       </a:r>
                       <a:endParaRPr lang="en-US" sz="1300" dirty="0">
-                        <a:latin typeface="Calibri" charset="0"/>
-                        <a:ea typeface="Calibri" charset="0"/>
-                        <a:cs typeface="Calibri" charset="0"/>
+                        <a:latin typeface="Arial" charset="0"/>
+                        <a:ea typeface="Arial" charset="0"/>
+                        <a:cs typeface="Arial" charset="0"/>
                       </a:endParaRPr>
                     </a:p>
                   </a:txBody>
@@ -10753,16 +9538,16 @@
                           <a:solidFill>
                             <a:srgbClr val="14181F"/>
                           </a:solidFill>
-                          <a:latin typeface="Calibri" pitchFamily="34" charset="0"/>
-                          <a:ea typeface="Calibri" pitchFamily="34" charset="-122"/>
-                          <a:cs typeface="Calibri" pitchFamily="34" charset="-120"/>
+                          <a:latin typeface="Arial" pitchFamily="34" charset="0"/>
+                          <a:ea typeface="Arial" pitchFamily="34" charset="-122"/>
+                          <a:cs typeface="Arial" pitchFamily="34" charset="-120"/>
                         </a:rPr>
                         <a:t>110</a:t>
                       </a:r>
                       <a:endParaRPr lang="en-US" sz="1300" dirty="0">
-                        <a:latin typeface="Calibri" charset="0"/>
-                        <a:ea typeface="Calibri" charset="0"/>
-                        <a:cs typeface="Calibri" charset="0"/>
+                        <a:latin typeface="Arial" charset="0"/>
+                        <a:ea typeface="Arial" charset="0"/>
+                        <a:cs typeface="Arial" charset="0"/>
                       </a:endParaRPr>
                     </a:p>
                   </a:txBody>
@@ -10800,16 +9585,16 @@
                           <a:solidFill>
                             <a:srgbClr val="14181F"/>
                           </a:solidFill>
-                          <a:latin typeface="Calibri" pitchFamily="34" charset="0"/>
-                          <a:ea typeface="Calibri" pitchFamily="34" charset="-122"/>
-                          <a:cs typeface="Calibri" pitchFamily="34" charset="-120"/>
+                          <a:latin typeface="Arial" pitchFamily="34" charset="0"/>
+                          <a:ea typeface="Arial" pitchFamily="34" charset="-122"/>
+                          <a:cs typeface="Arial" pitchFamily="34" charset="-120"/>
                         </a:rPr>
                         <a:t>1.26×</a:t>
                       </a:r>
                       <a:endParaRPr lang="en-US" sz="1300" dirty="0">
-                        <a:latin typeface="Calibri" charset="0"/>
-                        <a:ea typeface="Calibri" charset="0"/>
-                        <a:cs typeface="Calibri" charset="0"/>
+                        <a:latin typeface="Arial" charset="0"/>
+                        <a:ea typeface="Arial" charset="0"/>
+                        <a:cs typeface="Arial" charset="0"/>
                       </a:endParaRPr>
                     </a:p>
                   </a:txBody>
@@ -10849,16 +9634,16 @@
                           <a:solidFill>
                             <a:srgbClr val="14181F"/>
                           </a:solidFill>
-                          <a:latin typeface="Calibri" pitchFamily="34" charset="0"/>
-                          <a:ea typeface="Calibri" pitchFamily="34" charset="-122"/>
-                          <a:cs typeface="Calibri" pitchFamily="34" charset="-120"/>
+                          <a:latin typeface="Arial" pitchFamily="34" charset="0"/>
+                          <a:ea typeface="Arial" pitchFamily="34" charset="-122"/>
+                          <a:cs typeface="Arial" pitchFamily="34" charset="-120"/>
                         </a:rPr>
                         <a:t>transfers, Zipf 1.2</a:t>
                       </a:r>
                       <a:endParaRPr lang="en-US" sz="1300" dirty="0">
-                        <a:latin typeface="Calibri" charset="0"/>
-                        <a:ea typeface="Calibri" charset="0"/>
-                        <a:cs typeface="Calibri" charset="0"/>
+                        <a:latin typeface="Arial" charset="0"/>
+                        <a:ea typeface="Arial" charset="0"/>
+                        <a:cs typeface="Arial" charset="0"/>
                       </a:endParaRPr>
                     </a:p>
                   </a:txBody>
@@ -10896,16 +9681,16 @@
                           <a:solidFill>
                             <a:srgbClr val="14181F"/>
                           </a:solidFill>
-                          <a:latin typeface="Calibri" pitchFamily="34" charset="0"/>
-                          <a:ea typeface="Calibri" pitchFamily="34" charset="-122"/>
-                          <a:cs typeface="Calibri" pitchFamily="34" charset="-120"/>
+                          <a:latin typeface="Arial" pitchFamily="34" charset="0"/>
+                          <a:ea typeface="Arial" pitchFamily="34" charset="-122"/>
+                          <a:cs typeface="Arial" pitchFamily="34" charset="-120"/>
                         </a:rPr>
                         <a:t>0.90</a:t>
                       </a:r>
                       <a:endParaRPr lang="en-US" sz="1300" dirty="0">
-                        <a:latin typeface="Calibri" charset="0"/>
-                        <a:ea typeface="Calibri" charset="0"/>
-                        <a:cs typeface="Calibri" charset="0"/>
+                        <a:latin typeface="Arial" charset="0"/>
+                        <a:ea typeface="Arial" charset="0"/>
+                        <a:cs typeface="Arial" charset="0"/>
                       </a:endParaRPr>
                     </a:p>
                   </a:txBody>
@@ -10943,16 +9728,16 @@
                           <a:solidFill>
                             <a:srgbClr val="14181F"/>
                           </a:solidFill>
-                          <a:latin typeface="Calibri" pitchFamily="34" charset="0"/>
-                          <a:ea typeface="Calibri" pitchFamily="34" charset="-122"/>
-                          <a:cs typeface="Calibri" pitchFamily="34" charset="-120"/>
+                          <a:latin typeface="Arial" pitchFamily="34" charset="0"/>
+                          <a:ea typeface="Arial" pitchFamily="34" charset="-122"/>
+                          <a:cs typeface="Arial" pitchFamily="34" charset="-120"/>
                         </a:rPr>
                         <a:t>432</a:t>
                       </a:r>
                       <a:endParaRPr lang="en-US" sz="1300" dirty="0">
-                        <a:latin typeface="Calibri" charset="0"/>
-                        <a:ea typeface="Calibri" charset="0"/>
-                        <a:cs typeface="Calibri" charset="0"/>
+                        <a:latin typeface="Arial" charset="0"/>
+                        <a:ea typeface="Arial" charset="0"/>
+                        <a:cs typeface="Arial" charset="0"/>
                       </a:endParaRPr>
                     </a:p>
                   </a:txBody>
@@ -10990,16 +9775,16 @@
                           <a:solidFill>
                             <a:srgbClr val="14181F"/>
                           </a:solidFill>
-                          <a:latin typeface="Calibri" pitchFamily="34" charset="0"/>
-                          <a:ea typeface="Calibri" pitchFamily="34" charset="-122"/>
-                          <a:cs typeface="Calibri" pitchFamily="34" charset="-120"/>
+                          <a:latin typeface="Arial" pitchFamily="34" charset="0"/>
+                          <a:ea typeface="Arial" pitchFamily="34" charset="-122"/>
+                          <a:cs typeface="Arial" pitchFamily="34" charset="-120"/>
                         </a:rPr>
                         <a:t>1.07×</a:t>
                       </a:r>
                       <a:endParaRPr lang="en-US" sz="1300" dirty="0">
-                        <a:latin typeface="Calibri" charset="0"/>
-                        <a:ea typeface="Calibri" charset="0"/>
-                        <a:cs typeface="Calibri" charset="0"/>
+                        <a:latin typeface="Arial" charset="0"/>
+                        <a:ea typeface="Arial" charset="0"/>
+                        <a:cs typeface="Arial" charset="0"/>
                       </a:endParaRPr>
                     </a:p>
                   </a:txBody>
@@ -11039,16 +9824,16 @@
                           <a:solidFill>
                             <a:srgbClr val="14181F"/>
                           </a:solidFill>
-                          <a:latin typeface="Calibri" pitchFamily="34" charset="0"/>
-                          <a:ea typeface="Calibri" pitchFamily="34" charset="-122"/>
-                          <a:cs typeface="Calibri" pitchFamily="34" charset="-120"/>
+                          <a:latin typeface="Arial" pitchFamily="34" charset="0"/>
+                          <a:ea typeface="Arial" pitchFamily="34" charset="-122"/>
+                          <a:cs typeface="Arial" pitchFamily="34" charset="-120"/>
                         </a:rPr>
                         <a:t>ERC-20, Zipf 1.2</a:t>
                       </a:r>
                       <a:endParaRPr lang="en-US" sz="1300" dirty="0">
-                        <a:latin typeface="Calibri" charset="0"/>
-                        <a:ea typeface="Calibri" charset="0"/>
-                        <a:cs typeface="Calibri" charset="0"/>
+                        <a:latin typeface="Arial" charset="0"/>
+                        <a:ea typeface="Arial" charset="0"/>
+                        <a:cs typeface="Arial" charset="0"/>
                       </a:endParaRPr>
                     </a:p>
                   </a:txBody>
@@ -11086,16 +9871,16 @@
                           <a:solidFill>
                             <a:srgbClr val="14181F"/>
                           </a:solidFill>
-                          <a:latin typeface="Calibri" pitchFamily="34" charset="0"/>
-                          <a:ea typeface="Calibri" pitchFamily="34" charset="-122"/>
-                          <a:cs typeface="Calibri" pitchFamily="34" charset="-120"/>
+                          <a:latin typeface="Arial" pitchFamily="34" charset="0"/>
+                          <a:ea typeface="Arial" pitchFamily="34" charset="-122"/>
+                          <a:cs typeface="Arial" pitchFamily="34" charset="-120"/>
                         </a:rPr>
                         <a:t>0.90</a:t>
                       </a:r>
                       <a:endParaRPr lang="en-US" sz="1300" dirty="0">
-                        <a:latin typeface="Calibri" charset="0"/>
-                        <a:ea typeface="Calibri" charset="0"/>
-                        <a:cs typeface="Calibri" charset="0"/>
+                        <a:latin typeface="Arial" charset="0"/>
+                        <a:ea typeface="Arial" charset="0"/>
+                        <a:cs typeface="Arial" charset="0"/>
                       </a:endParaRPr>
                     </a:p>
                   </a:txBody>
@@ -11133,16 +9918,16 @@
                           <a:solidFill>
                             <a:srgbClr val="14181F"/>
                           </a:solidFill>
-                          <a:latin typeface="Calibri" pitchFamily="34" charset="0"/>
-                          <a:ea typeface="Calibri" pitchFamily="34" charset="-122"/>
-                          <a:cs typeface="Calibri" pitchFamily="34" charset="-120"/>
+                          <a:latin typeface="Arial" pitchFamily="34" charset="0"/>
+                          <a:ea typeface="Arial" pitchFamily="34" charset="-122"/>
+                          <a:cs typeface="Arial" pitchFamily="34" charset="-120"/>
                         </a:rPr>
                         <a:t>432</a:t>
                       </a:r>
                       <a:endParaRPr lang="en-US" sz="1300" dirty="0">
-                        <a:latin typeface="Calibri" charset="0"/>
-                        <a:ea typeface="Calibri" charset="0"/>
-                        <a:cs typeface="Calibri" charset="0"/>
+                        <a:latin typeface="Arial" charset="0"/>
+                        <a:ea typeface="Arial" charset="0"/>
+                        <a:cs typeface="Arial" charset="0"/>
                       </a:endParaRPr>
                     </a:p>
                   </a:txBody>
@@ -11180,16 +9965,16 @@
                           <a:solidFill>
                             <a:srgbClr val="14181F"/>
                           </a:solidFill>
-                          <a:latin typeface="Calibri" pitchFamily="34" charset="0"/>
-                          <a:ea typeface="Calibri" pitchFamily="34" charset="-122"/>
-                          <a:cs typeface="Calibri" pitchFamily="34" charset="-120"/>
+                          <a:latin typeface="Arial" pitchFamily="34" charset="0"/>
+                          <a:ea typeface="Arial" pitchFamily="34" charset="-122"/>
+                          <a:cs typeface="Arial" pitchFamily="34" charset="-120"/>
                         </a:rPr>
                         <a:t>1.67×</a:t>
                       </a:r>
                       <a:endParaRPr lang="en-US" sz="1300" dirty="0">
-                        <a:latin typeface="Calibri" charset="0"/>
-                        <a:ea typeface="Calibri" charset="0"/>
-                        <a:cs typeface="Calibri" charset="0"/>
+                        <a:latin typeface="Arial" charset="0"/>
+                        <a:ea typeface="Arial" charset="0"/>
+                        <a:cs typeface="Arial" charset="0"/>
                       </a:endParaRPr>
                     </a:p>
                   </a:txBody>
@@ -11229,16 +10014,16 @@
                           <a:solidFill>
                             <a:srgbClr val="14181F"/>
                           </a:solidFill>
-                          <a:latin typeface="Calibri" pitchFamily="34" charset="0"/>
-                          <a:ea typeface="Calibri" pitchFamily="34" charset="-122"/>
-                          <a:cs typeface="Calibri" pitchFamily="34" charset="-120"/>
+                          <a:latin typeface="Arial" pitchFamily="34" charset="0"/>
+                          <a:ea typeface="Arial" pitchFamily="34" charset="-122"/>
+                          <a:cs typeface="Arial" pitchFamily="34" charset="-120"/>
                         </a:rPr>
                         <a:t>transfers, Zipf 2.0</a:t>
                       </a:r>
                       <a:endParaRPr lang="en-US" sz="1300" dirty="0">
-                        <a:latin typeface="Calibri" charset="0"/>
-                        <a:ea typeface="Calibri" charset="0"/>
-                        <a:cs typeface="Calibri" charset="0"/>
+                        <a:latin typeface="Arial" charset="0"/>
+                        <a:ea typeface="Arial" charset="0"/>
+                        <a:cs typeface="Arial" charset="0"/>
                       </a:endParaRPr>
                     </a:p>
                   </a:txBody>
@@ -11276,16 +10061,16 @@
                           <a:solidFill>
                             <a:srgbClr val="14181F"/>
                           </a:solidFill>
-                          <a:latin typeface="Calibri" pitchFamily="34" charset="0"/>
-                          <a:ea typeface="Calibri" pitchFamily="34" charset="-122"/>
-                          <a:cs typeface="Calibri" pitchFamily="34" charset="-120"/>
+                          <a:latin typeface="Arial" pitchFamily="34" charset="0"/>
+                          <a:ea typeface="Arial" pitchFamily="34" charset="-122"/>
+                          <a:cs typeface="Arial" pitchFamily="34" charset="-120"/>
                         </a:rPr>
                         <a:t>0.98</a:t>
                       </a:r>
                       <a:endParaRPr lang="en-US" sz="1300" dirty="0">
-                        <a:latin typeface="Calibri" charset="0"/>
-                        <a:ea typeface="Calibri" charset="0"/>
-                        <a:cs typeface="Calibri" charset="0"/>
+                        <a:latin typeface="Arial" charset="0"/>
+                        <a:ea typeface="Arial" charset="0"/>
+                        <a:cs typeface="Arial" charset="0"/>
                       </a:endParaRPr>
                     </a:p>
                   </a:txBody>
@@ -11323,16 +10108,16 @@
                           <a:solidFill>
                             <a:srgbClr val="14181F"/>
                           </a:solidFill>
-                          <a:latin typeface="Calibri" pitchFamily="34" charset="0"/>
-                          <a:ea typeface="Calibri" pitchFamily="34" charset="-122"/>
-                          <a:cs typeface="Calibri" pitchFamily="34" charset="-120"/>
+                          <a:latin typeface="Arial" pitchFamily="34" charset="0"/>
+                          <a:ea typeface="Arial" pitchFamily="34" charset="-122"/>
+                          <a:cs typeface="Arial" pitchFamily="34" charset="-120"/>
                         </a:rPr>
                         <a:t>1,217</a:t>
                       </a:r>
                       <a:endParaRPr lang="en-US" sz="1300" dirty="0">
-                        <a:latin typeface="Calibri" charset="0"/>
-                        <a:ea typeface="Calibri" charset="0"/>
-                        <a:cs typeface="Calibri" charset="0"/>
+                        <a:latin typeface="Arial" charset="0"/>
+                        <a:ea typeface="Arial" charset="0"/>
+                        <a:cs typeface="Arial" charset="0"/>
                       </a:endParaRPr>
                     </a:p>
                   </a:txBody>
@@ -11370,16 +10155,16 @@
                           <a:solidFill>
                             <a:srgbClr val="EB6834"/>
                           </a:solidFill>
-                          <a:latin typeface="Calibri" pitchFamily="34" charset="0"/>
-                          <a:ea typeface="Calibri" pitchFamily="34" charset="-122"/>
-                          <a:cs typeface="Calibri" pitchFamily="34" charset="-120"/>
+                          <a:latin typeface="Arial" pitchFamily="34" charset="0"/>
+                          <a:ea typeface="Arial" pitchFamily="34" charset="-122"/>
+                          <a:cs typeface="Arial" pitchFamily="34" charset="-120"/>
                         </a:rPr>
                         <a:t>0.45×</a:t>
                       </a:r>
                       <a:endParaRPr lang="en-US" sz="1300" dirty="0">
-                        <a:latin typeface="Calibri" charset="0"/>
-                        <a:ea typeface="Calibri" charset="0"/>
-                        <a:cs typeface="Calibri" charset="0"/>
+                        <a:latin typeface="Arial" charset="0"/>
+                        <a:ea typeface="Arial" charset="0"/>
+                        <a:cs typeface="Arial" charset="0"/>
                       </a:endParaRPr>
                     </a:p>
                   </a:txBody>
@@ -11419,16 +10204,16 @@
                           <a:solidFill>
                             <a:srgbClr val="14181F"/>
                           </a:solidFill>
-                          <a:latin typeface="Calibri" pitchFamily="34" charset="0"/>
-                          <a:ea typeface="Calibri" pitchFamily="34" charset="-122"/>
-                          <a:cs typeface="Calibri" pitchFamily="34" charset="-120"/>
+                          <a:latin typeface="Arial" pitchFamily="34" charset="0"/>
+                          <a:ea typeface="Arial" pitchFamily="34" charset="-122"/>
+                          <a:cs typeface="Arial" pitchFamily="34" charset="-120"/>
                         </a:rPr>
                         <a:t>NFT mint</a:t>
                       </a:r>
                       <a:endParaRPr lang="en-US" sz="1300" dirty="0">
-                        <a:latin typeface="Calibri" charset="0"/>
-                        <a:ea typeface="Calibri" charset="0"/>
-                        <a:cs typeface="Calibri" charset="0"/>
+                        <a:latin typeface="Arial" charset="0"/>
+                        <a:ea typeface="Arial" charset="0"/>
+                        <a:cs typeface="Arial" charset="0"/>
                       </a:endParaRPr>
                     </a:p>
                   </a:txBody>
@@ -11466,16 +10251,16 @@
                           <a:solidFill>
                             <a:srgbClr val="14181F"/>
                           </a:solidFill>
-                          <a:latin typeface="Calibri" pitchFamily="34" charset="0"/>
-                          <a:ea typeface="Calibri" pitchFamily="34" charset="-122"/>
-                          <a:cs typeface="Calibri" pitchFamily="34" charset="-120"/>
+                          <a:latin typeface="Arial" pitchFamily="34" charset="0"/>
+                          <a:ea typeface="Arial" pitchFamily="34" charset="-122"/>
+                          <a:cs typeface="Arial" pitchFamily="34" charset="-120"/>
                         </a:rPr>
                         <a:t>1.00</a:t>
                       </a:r>
                       <a:endParaRPr lang="en-US" sz="1300" dirty="0">
-                        <a:latin typeface="Calibri" charset="0"/>
-                        <a:ea typeface="Calibri" charset="0"/>
-                        <a:cs typeface="Calibri" charset="0"/>
+                        <a:latin typeface="Arial" charset="0"/>
+                        <a:ea typeface="Arial" charset="0"/>
+                        <a:cs typeface="Arial" charset="0"/>
                       </a:endParaRPr>
                     </a:p>
                   </a:txBody>
@@ -11513,16 +10298,16 @@
                           <a:solidFill>
                             <a:srgbClr val="14181F"/>
                           </a:solidFill>
-                          <a:latin typeface="Calibri" pitchFamily="34" charset="0"/>
-                          <a:ea typeface="Calibri" pitchFamily="34" charset="-122"/>
-                          <a:cs typeface="Calibri" pitchFamily="34" charset="-120"/>
+                          <a:latin typeface="Arial" pitchFamily="34" charset="0"/>
+                          <a:ea typeface="Arial" pitchFamily="34" charset="-122"/>
+                          <a:cs typeface="Arial" pitchFamily="34" charset="-120"/>
                         </a:rPr>
                         <a:t>2,000</a:t>
                       </a:r>
                       <a:endParaRPr lang="en-US" sz="1300" dirty="0">
-                        <a:latin typeface="Calibri" charset="0"/>
-                        <a:ea typeface="Calibri" charset="0"/>
-                        <a:cs typeface="Calibri" charset="0"/>
+                        <a:latin typeface="Arial" charset="0"/>
+                        <a:ea typeface="Arial" charset="0"/>
+                        <a:cs typeface="Arial" charset="0"/>
                       </a:endParaRPr>
                     </a:p>
                   </a:txBody>
@@ -11560,16 +10345,16 @@
                           <a:solidFill>
                             <a:srgbClr val="EB6834"/>
                           </a:solidFill>
-                          <a:latin typeface="Calibri" pitchFamily="34" charset="0"/>
-                          <a:ea typeface="Calibri" pitchFamily="34" charset="-122"/>
-                          <a:cs typeface="Calibri" pitchFamily="34" charset="-120"/>
+                          <a:latin typeface="Arial" pitchFamily="34" charset="0"/>
+                          <a:ea typeface="Arial" pitchFamily="34" charset="-122"/>
+                          <a:cs typeface="Arial" pitchFamily="34" charset="-120"/>
                         </a:rPr>
                         <a:t>0.43×</a:t>
                       </a:r>
                       <a:endParaRPr lang="en-US" sz="1300" dirty="0">
-                        <a:latin typeface="Calibri" charset="0"/>
-                        <a:ea typeface="Calibri" charset="0"/>
-                        <a:cs typeface="Calibri" charset="0"/>
+                        <a:latin typeface="Arial" charset="0"/>
+                        <a:ea typeface="Arial" charset="0"/>
+                        <a:cs typeface="Arial" charset="0"/>
                       </a:endParaRPr>
                     </a:p>
                   </a:txBody>
@@ -11631,9 +10416,9 @@
                 <a:solidFill>
                   <a:srgbClr val="14181F"/>
                 </a:solidFill>
-                <a:latin typeface="Calibri" pitchFamily="34" charset="0"/>
-                <a:ea typeface="Calibri" pitchFamily="34" charset="-122"/>
-                <a:cs typeface="Calibri" pitchFamily="34" charset="-120"/>
+                <a:latin typeface="Arial" pitchFamily="34" charset="0"/>
+                <a:ea typeface="Arial" pitchFamily="34" charset="-122"/>
+                <a:cs typeface="Arial" pitchFamily="34" charset="-120"/>
               </a:rPr>
               <a:t>Same chain, more work per transaction: ERC-20 gets 1.67× where transfers get 1.07×. Density alone does not describe a workload.</a:t>
             </a:r>
@@ -11670,9 +10455,9 @@
                 <a:solidFill>
                   <a:srgbClr val="5A6272"/>
                 </a:solidFill>
-                <a:latin typeface="Calibri" pitchFamily="34" charset="0"/>
-                <a:ea typeface="Calibri" pitchFamily="34" charset="-122"/>
-                <a:cs typeface="Calibri" pitchFamily="34" charset="-120"/>
+                <a:latin typeface="Arial" pitchFamily="34" charset="0"/>
+                <a:ea typeface="Arial" pitchFamily="34" charset="-122"/>
+                <a:cs typeface="Arial" pitchFamily="34" charset="-120"/>
               </a:rPr>
               <a:t>Density: fraction of transactions reading an earlier transaction's write, measured from a real execution.</a:t>
             </a:r>
@@ -11741,9 +10526,9 @@
                 <a:solidFill>
                   <a:srgbClr val="EB6834"/>
                 </a:solidFill>
-                <a:latin typeface="Calibri" pitchFamily="34" charset="0"/>
-                <a:ea typeface="Calibri" pitchFamily="34" charset="-122"/>
-                <a:cs typeface="Calibri" pitchFamily="34" charset="-120"/>
+                <a:latin typeface="Arial" pitchFamily="34" charset="0"/>
+                <a:ea typeface="Arial" pitchFamily="34" charset="-122"/>
+                <a:cs typeface="Arial" pitchFamily="34" charset="-120"/>
               </a:rPr>
               <a:t>RESULT 3</a:t>
             </a:r>
@@ -11776,36 +10561,44 @@
               <a:buNone/>
             </a:pPr>
             <a:r>
-              <a:rPr lang="en-US" sz="3200" b="1" dirty="0">
+              <a:rPr lang="en-US" sz="2800" b="1" dirty="0">
                 <a:solidFill>
                   <a:srgbClr val="14181F"/>
                 </a:solidFill>
-                <a:latin typeface="Calibri" pitchFamily="34" charset="0"/>
-                <a:ea typeface="Calibri" pitchFamily="34" charset="-122"/>
-                <a:cs typeface="Calibri" pitchFamily="34" charset="-120"/>
+                <a:latin typeface="Arial" pitchFamily="34" charset="0"/>
+                <a:ea typeface="Arial" pitchFamily="34" charset="-122"/>
+                <a:cs typeface="Arial" pitchFamily="34" charset="-120"/>
               </a:rPr>
               <a:t>A transaction has to do more work than it costs to coordinate</a:t>
             </a:r>
-            <a:endParaRPr lang="en-US" sz="3200" dirty="0"/>
-          </a:p>
-        </p:txBody>
-      </p:sp>
-      <p:graphicFrame>
-        <p:nvGraphicFramePr>
-          <p:cNvPr id="4" name="Chart 0" descr=""/>
-          <p:cNvGraphicFramePr/>
-          <p:nvPr/>
-        </p:nvGraphicFramePr>
-        <p:xfrm>
-          <a:off x="548640" y="1371600"/>
-          <a:ext cx="7315200" cy="4754880"/>
-        </p:xfrm>
-        <a:graphic xmlns:a="http://schemas.openxmlformats.org/drawingml/2006/main">
-          <a:graphicData uri="http://schemas.openxmlformats.org/drawingml/2006/chart">
-            <c:chart xmlns:c="http://schemas.openxmlformats.org/drawingml/2006/chart" r:id="rId1"/>
-          </a:graphicData>
-        </a:graphic>
-      </p:graphicFrame>
+            <a:endParaRPr lang="en-US" sz="2800" dirty="0"/>
+          </a:p>
+        </p:txBody>
+      </p:sp>
+      <p:pic>
+        <p:nvPicPr>
+          <p:cNvPr id="4" name="Image 0" descr="/Users/franz/Desktop/SC6109/docs/figures/fig3_speedup_by_work.png">    </p:cNvPr>
+          <p:cNvPicPr>
+            <a:picLocks noChangeAspect="1"/>
+          </p:cNvPicPr>
+          <p:nvPr/>
+        </p:nvPicPr>
+        <p:blipFill>
+          <a:blip r:embed="rId1"/>
+          <a:stretch>
+            <a:fillRect/>
+          </a:stretch>
+        </p:blipFill>
+        <p:spPr>
+          <a:xfrm>
+            <a:off x="548640" y="1463040"/>
+            <a:ext cx="7315200" cy="4149291"/>
+          </a:xfrm>
+          <a:prstGeom prst="rect">
+            <a:avLst/>
+          </a:prstGeom>
+        </p:spPr>
+      </p:pic>
       <p:sp>
         <p:nvSpPr>
           <p:cNvPr id="5" name="Text 2"/>
@@ -11835,9 +10628,9 @@
                 <a:solidFill>
                   <a:srgbClr val="EB6834"/>
                 </a:solidFill>
-                <a:latin typeface="Calibri" pitchFamily="34" charset="0"/>
-                <a:ea typeface="Calibri" pitchFamily="34" charset="-122"/>
-                <a:cs typeface="Calibri" pitchFamily="34" charset="-120"/>
+                <a:latin typeface="Arial" pitchFamily="34" charset="0"/>
+                <a:ea typeface="Arial" pitchFamily="34" charset="-122"/>
+                <a:cs typeface="Arial" pitchFamily="34" charset="-120"/>
               </a:rPr>
               <a:t>~40%</a:t>
             </a:r>
@@ -11874,9 +10667,9 @@
                 <a:solidFill>
                   <a:srgbClr val="5A6272"/>
                 </a:solidFill>
-                <a:latin typeface="Calibri" pitchFamily="34" charset="0"/>
-                <a:ea typeface="Calibri" pitchFamily="34" charset="-122"/>
-                <a:cs typeface="Calibri" pitchFamily="34" charset="-120"/>
+                <a:latin typeface="Arial" pitchFamily="34" charset="0"/>
+                <a:ea typeface="Arial" pitchFamily="34" charset="-122"/>
+                <a:cs typeface="Arial" pitchFamily="34" charset="-120"/>
               </a:rPr>
               <a:t>of sequential throughput lost to Block-STM's own machinery at one thread, on light transactions</a:t>
             </a:r>
@@ -11913,9 +10706,9 @@
                 <a:solidFill>
                   <a:srgbClr val="1BAF7A"/>
                 </a:solidFill>
-                <a:latin typeface="Calibri" pitchFamily="34" charset="0"/>
-                <a:ea typeface="Calibri" pitchFamily="34" charset="-122"/>
-                <a:cs typeface="Calibri" pitchFamily="34" charset="-120"/>
+                <a:latin typeface="Arial" pitchFamily="34" charset="0"/>
+                <a:ea typeface="Arial" pitchFamily="34" charset="-122"/>
+                <a:cs typeface="Arial" pitchFamily="34" charset="-120"/>
               </a:rPr>
               <a:t>92%</a:t>
             </a:r>
@@ -11952,9 +10745,9 @@
                 <a:solidFill>
                   <a:srgbClr val="5A6272"/>
                 </a:solidFill>
-                <a:latin typeface="Calibri" pitchFamily="34" charset="0"/>
-                <a:ea typeface="Calibri" pitchFamily="34" charset="-122"/>
-                <a:cs typeface="Calibri" pitchFamily="34" charset="-120"/>
+                <a:latin typeface="Arial" pitchFamily="34" charset="0"/>
+                <a:ea typeface="Arial" pitchFamily="34" charset="-122"/>
+                <a:cs typeface="Arial" pitchFamily="34" charset="-120"/>
               </a:rPr>
               <a:t>of linear on 6 cores once each transaction does ~78 µs of work</a:t>
             </a:r>
@@ -11991,9 +10784,9 @@
                 <a:solidFill>
                   <a:srgbClr val="5A6272"/>
                 </a:solidFill>
-                <a:latin typeface="Calibri" pitchFamily="34" charset="0"/>
-                <a:ea typeface="Calibri" pitchFamily="34" charset="-122"/>
-                <a:cs typeface="Calibri" pitchFamily="34" charset="-120"/>
+                <a:latin typeface="Arial" pitchFamily="34" charset="0"/>
+                <a:ea typeface="Arial" pitchFamily="34" charset="-122"/>
+                <a:cs typeface="Arial" pitchFamily="34" charset="-120"/>
               </a:rPr>
               <a:t>sha256 precompile calls with a growing payload; conflicts held near zero.</a:t>
             </a:r>

</xml_diff>